<commit_message>
Add star schema page (unification logic), fix MCD title
</commit_message>
<xml_diff>
--- a/diagram/architecture-edge-cloud.pptx
+++ b/diagram/architecture-edge-cloud.pptx
@@ -7,6 +7,7 @@
   <p:sldIdLst>
     <p:sldId id="256" r:id="rId7"/>
     <p:sldId id="257" r:id="rId8"/>
+    <p:sldId id="258" r:id="rId9"/>
   </p:sldIdLst>
   <p:sldSz cx="12191695" cy="6858000" type="screen4x3"/>
   <p:notesSz cx="6858000" cy="9144000"/>
@@ -7664,7 +7665,7 @@
         </p:nvSpPr>
         <p:spPr>
           <a:xfrm>
-            <a:off x="457200" y="91440"/>
+            <a:off x="457200" y="182880"/>
             <a:ext cx="11247120" cy="411480"/>
           </a:xfrm>
           <a:prstGeom prst="rect">
@@ -7680,13 +7681,13 @@
           <a:p>
             <a:pPr algn="l"/>
             <a:r>
-              <a:rPr sz="2000" b="1" i="0">
+              <a:rPr sz="2200" b="1" i="0">
                 <a:solidFill>
                   <a:srgbClr val="FFFFFF"/>
                 </a:solidFill>
                 <a:latin typeface="Segoe UI"/>
               </a:rPr>
-              <a:t>Explication détaillée du Modèle Conceptuel de données</a:t>
+              <a:t>Modèle Conceptuel de Données (MCD)</a:t>
             </a:r>
           </a:p>
         </p:txBody>
@@ -7699,8 +7700,8 @@
         </p:nvSpPr>
         <p:spPr>
           <a:xfrm>
-            <a:off x="457200" y="484632"/>
-            <a:ext cx="11247120" cy="274320"/>
+            <a:off x="457200" y="603504"/>
+            <a:ext cx="11247120" cy="219456"/>
           </a:xfrm>
           <a:prstGeom prst="rect">
             <a:avLst/>
@@ -7715,55 +7716,20 @@
           <a:p>
             <a:pPr algn="l"/>
             <a:r>
-              <a:rPr sz="1500" b="1" i="0">
+              <a:rPr sz="950" b="0" i="1">
                 <a:solidFill>
                   <a:srgbClr val="F5C344"/>
                 </a:solidFill>
                 <a:latin typeface="Segoe UI"/>
               </a:rPr>
-              <a:t>en schéma étoile</a:t>
-            </a:r>
-          </a:p>
-        </p:txBody>
-      </p:sp>
-      <p:sp>
-        <p:nvSpPr>
-          <p:cNvPr id="5" name="TextBox 4"/>
-          <p:cNvSpPr txBox="1"/>
-          <p:nvPr/>
-        </p:nvSpPr>
-        <p:spPr>
-          <a:xfrm>
-            <a:off x="457200" y="749808"/>
-            <a:ext cx="11247120" cy="182880"/>
-          </a:xfrm>
-          <a:prstGeom prst="rect">
-            <a:avLst/>
-          </a:prstGeom>
-          <a:noFill/>
-        </p:spPr>
-        <p:txBody>
-          <a:bodyPr wrap="square" lIns="0" rIns="0" tIns="0" bIns="0">
-            <a:spAutoFit/>
-          </a:bodyPr>
-          <a:lstStyle/>
-          <a:p>
-            <a:pPr algn="l"/>
-            <a:r>
-              <a:rPr sz="950" b="0" i="1">
-                <a:solidFill>
-                  <a:srgbClr val="F5C344"/>
-                </a:solidFill>
-                <a:latin typeface="Segoe UI"/>
-              </a:rPr>
-              <a:t>Bloc 2 — AutoMeca Systems — niveau conceptuel (Merise), traduit ensuite en schéma en étoile physique</a:t>
-            </a:r>
-          </a:p>
-        </p:txBody>
-      </p:sp>
-      <p:sp>
-        <p:nvSpPr>
-          <p:cNvPr id="6" name="Rectangle 5"/>
+              <a:t>Bloc 2 — AutoMeca Systems — niveau conceptuel (Merise), indépendant de toute optimisation technique (voir page 3 pour le schéma en étoile physique)</a:t>
+            </a:r>
+          </a:p>
+        </p:txBody>
+      </p:sp>
+      <p:sp>
+        <p:nvSpPr>
+          <p:cNvPr id="5" name="Rectangle 4"/>
           <p:cNvSpPr/>
           <p:nvPr/>
         </p:nvSpPr>
@@ -7809,7 +7775,7 @@
       </p:sp>
       <p:sp>
         <p:nvSpPr>
-          <p:cNvPr id="7" name="Rectangle 6"/>
+          <p:cNvPr id="6" name="Rectangle 5"/>
           <p:cNvSpPr/>
           <p:nvPr/>
         </p:nvSpPr>
@@ -7853,7 +7819,7 @@
       </p:sp>
       <p:sp>
         <p:nvSpPr>
-          <p:cNvPr id="8" name="TextBox 7"/>
+          <p:cNvPr id="7" name="TextBox 6"/>
           <p:cNvSpPr txBox="1"/>
           <p:nvPr/>
         </p:nvSpPr>
@@ -7888,7 +7854,7 @@
       </p:sp>
       <p:sp>
         <p:nvSpPr>
-          <p:cNvPr id="9" name="TextBox 8"/>
+          <p:cNvPr id="8" name="TextBox 7"/>
           <p:cNvSpPr txBox="1"/>
           <p:nvPr/>
         </p:nvSpPr>
@@ -7922,7 +7888,7 @@
       </p:sp>
       <p:sp>
         <p:nvSpPr>
-          <p:cNvPr id="10" name="TextBox 9"/>
+          <p:cNvPr id="9" name="TextBox 8"/>
           <p:cNvSpPr txBox="1"/>
           <p:nvPr/>
         </p:nvSpPr>
@@ -7956,7 +7922,7 @@
       </p:sp>
       <p:sp>
         <p:nvSpPr>
-          <p:cNvPr id="11" name="TextBox 10"/>
+          <p:cNvPr id="10" name="TextBox 9"/>
           <p:cNvSpPr txBox="1"/>
           <p:nvPr/>
         </p:nvSpPr>
@@ -7990,7 +7956,7 @@
       </p:sp>
       <p:sp>
         <p:nvSpPr>
-          <p:cNvPr id="12" name="Rectangle 11"/>
+          <p:cNvPr id="11" name="Rectangle 10"/>
           <p:cNvSpPr/>
           <p:nvPr/>
         </p:nvSpPr>
@@ -8036,7 +8002,7 @@
       </p:sp>
       <p:sp>
         <p:nvSpPr>
-          <p:cNvPr id="13" name="Rectangle 12"/>
+          <p:cNvPr id="12" name="Rectangle 11"/>
           <p:cNvSpPr/>
           <p:nvPr/>
         </p:nvSpPr>
@@ -8080,7 +8046,7 @@
       </p:sp>
       <p:sp>
         <p:nvSpPr>
-          <p:cNvPr id="14" name="TextBox 13"/>
+          <p:cNvPr id="13" name="TextBox 12"/>
           <p:cNvSpPr txBox="1"/>
           <p:nvPr/>
         </p:nvSpPr>
@@ -8115,7 +8081,7 @@
       </p:sp>
       <p:sp>
         <p:nvSpPr>
-          <p:cNvPr id="15" name="TextBox 14"/>
+          <p:cNvPr id="14" name="TextBox 13"/>
           <p:cNvSpPr txBox="1"/>
           <p:nvPr/>
         </p:nvSpPr>
@@ -8149,7 +8115,7 @@
       </p:sp>
       <p:sp>
         <p:nvSpPr>
-          <p:cNvPr id="16" name="TextBox 15"/>
+          <p:cNvPr id="15" name="TextBox 14"/>
           <p:cNvSpPr txBox="1"/>
           <p:nvPr/>
         </p:nvSpPr>
@@ -8183,7 +8149,7 @@
       </p:sp>
       <p:sp>
         <p:nvSpPr>
-          <p:cNvPr id="17" name="TextBox 16"/>
+          <p:cNvPr id="16" name="TextBox 15"/>
           <p:cNvSpPr txBox="1"/>
           <p:nvPr/>
         </p:nvSpPr>
@@ -8217,7 +8183,7 @@
       </p:sp>
       <p:sp>
         <p:nvSpPr>
-          <p:cNvPr id="18" name="Rectangle 17"/>
+          <p:cNvPr id="17" name="Rectangle 16"/>
           <p:cNvSpPr/>
           <p:nvPr/>
         </p:nvSpPr>
@@ -8263,7 +8229,7 @@
       </p:sp>
       <p:sp>
         <p:nvSpPr>
-          <p:cNvPr id="19" name="Rectangle 18"/>
+          <p:cNvPr id="18" name="Rectangle 17"/>
           <p:cNvSpPr/>
           <p:nvPr/>
         </p:nvSpPr>
@@ -8307,7 +8273,7 @@
       </p:sp>
       <p:sp>
         <p:nvSpPr>
-          <p:cNvPr id="20" name="TextBox 19"/>
+          <p:cNvPr id="19" name="TextBox 18"/>
           <p:cNvSpPr txBox="1"/>
           <p:nvPr/>
         </p:nvSpPr>
@@ -8342,7 +8308,7 @@
       </p:sp>
       <p:sp>
         <p:nvSpPr>
-          <p:cNvPr id="21" name="TextBox 20"/>
+          <p:cNvPr id="20" name="TextBox 19"/>
           <p:cNvSpPr txBox="1"/>
           <p:nvPr/>
         </p:nvSpPr>
@@ -8376,7 +8342,7 @@
       </p:sp>
       <p:sp>
         <p:nvSpPr>
-          <p:cNvPr id="22" name="TextBox 21"/>
+          <p:cNvPr id="21" name="TextBox 20"/>
           <p:cNvSpPr txBox="1"/>
           <p:nvPr/>
         </p:nvSpPr>
@@ -8410,7 +8376,7 @@
       </p:sp>
       <p:sp>
         <p:nvSpPr>
-          <p:cNvPr id="23" name="Rectangle 22"/>
+          <p:cNvPr id="22" name="Rectangle 21"/>
           <p:cNvSpPr/>
           <p:nvPr/>
         </p:nvSpPr>
@@ -8456,7 +8422,7 @@
       </p:sp>
       <p:sp>
         <p:nvSpPr>
-          <p:cNvPr id="24" name="Rectangle 23"/>
+          <p:cNvPr id="23" name="Rectangle 22"/>
           <p:cNvSpPr/>
           <p:nvPr/>
         </p:nvSpPr>
@@ -8500,7 +8466,7 @@
       </p:sp>
       <p:sp>
         <p:nvSpPr>
-          <p:cNvPr id="25" name="TextBox 24"/>
+          <p:cNvPr id="24" name="TextBox 23"/>
           <p:cNvSpPr txBox="1"/>
           <p:nvPr/>
         </p:nvSpPr>
@@ -8535,7 +8501,7 @@
       </p:sp>
       <p:sp>
         <p:nvSpPr>
-          <p:cNvPr id="26" name="TextBox 25"/>
+          <p:cNvPr id="25" name="TextBox 24"/>
           <p:cNvSpPr txBox="1"/>
           <p:nvPr/>
         </p:nvSpPr>
@@ -8569,7 +8535,7 @@
       </p:sp>
       <p:sp>
         <p:nvSpPr>
-          <p:cNvPr id="27" name="TextBox 26"/>
+          <p:cNvPr id="26" name="TextBox 25"/>
           <p:cNvSpPr txBox="1"/>
           <p:nvPr/>
         </p:nvSpPr>
@@ -8603,7 +8569,7 @@
       </p:sp>
       <p:sp>
         <p:nvSpPr>
-          <p:cNvPr id="28" name="Rectangle 27"/>
+          <p:cNvPr id="27" name="Rectangle 26"/>
           <p:cNvSpPr/>
           <p:nvPr/>
         </p:nvSpPr>
@@ -8649,7 +8615,7 @@
       </p:sp>
       <p:sp>
         <p:nvSpPr>
-          <p:cNvPr id="29" name="Rectangle 28"/>
+          <p:cNvPr id="28" name="Rectangle 27"/>
           <p:cNvSpPr/>
           <p:nvPr/>
         </p:nvSpPr>
@@ -8693,7 +8659,7 @@
       </p:sp>
       <p:sp>
         <p:nvSpPr>
-          <p:cNvPr id="30" name="TextBox 29"/>
+          <p:cNvPr id="29" name="TextBox 28"/>
           <p:cNvSpPr txBox="1"/>
           <p:nvPr/>
         </p:nvSpPr>
@@ -8728,7 +8694,7 @@
       </p:sp>
       <p:sp>
         <p:nvSpPr>
-          <p:cNvPr id="31" name="TextBox 30"/>
+          <p:cNvPr id="30" name="TextBox 29"/>
           <p:cNvSpPr txBox="1"/>
           <p:nvPr/>
         </p:nvSpPr>
@@ -8762,7 +8728,7 @@
       </p:sp>
       <p:sp>
         <p:nvSpPr>
-          <p:cNvPr id="32" name="TextBox 31"/>
+          <p:cNvPr id="31" name="TextBox 30"/>
           <p:cNvSpPr txBox="1"/>
           <p:nvPr/>
         </p:nvSpPr>
@@ -8796,7 +8762,7 @@
       </p:sp>
       <p:sp>
         <p:nvSpPr>
-          <p:cNvPr id="33" name="TextBox 32"/>
+          <p:cNvPr id="32" name="TextBox 31"/>
           <p:cNvSpPr txBox="1"/>
           <p:nvPr/>
         </p:nvSpPr>
@@ -8830,7 +8796,7 @@
       </p:sp>
       <p:sp>
         <p:nvSpPr>
-          <p:cNvPr id="34" name="TextBox 33"/>
+          <p:cNvPr id="33" name="TextBox 32"/>
           <p:cNvSpPr txBox="1"/>
           <p:nvPr/>
         </p:nvSpPr>
@@ -8864,7 +8830,7 @@
       </p:sp>
       <p:sp>
         <p:nvSpPr>
-          <p:cNvPr id="35" name="TextBox 34"/>
+          <p:cNvPr id="34" name="TextBox 33"/>
           <p:cNvSpPr txBox="1"/>
           <p:nvPr/>
         </p:nvSpPr>
@@ -8898,7 +8864,7 @@
       </p:sp>
       <p:sp>
         <p:nvSpPr>
-          <p:cNvPr id="36" name="TextBox 35"/>
+          <p:cNvPr id="35" name="TextBox 34"/>
           <p:cNvSpPr txBox="1"/>
           <p:nvPr/>
         </p:nvSpPr>
@@ -8932,7 +8898,7 @@
       </p:sp>
       <p:sp>
         <p:nvSpPr>
-          <p:cNvPr id="37" name="Rectangle 36"/>
+          <p:cNvPr id="36" name="Rectangle 35"/>
           <p:cNvSpPr/>
           <p:nvPr/>
         </p:nvSpPr>
@@ -8978,7 +8944,7 @@
       </p:sp>
       <p:sp>
         <p:nvSpPr>
-          <p:cNvPr id="38" name="Rectangle 37"/>
+          <p:cNvPr id="37" name="Rectangle 36"/>
           <p:cNvSpPr/>
           <p:nvPr/>
         </p:nvSpPr>
@@ -9022,7 +8988,7 @@
       </p:sp>
       <p:sp>
         <p:nvSpPr>
-          <p:cNvPr id="39" name="TextBox 38"/>
+          <p:cNvPr id="38" name="TextBox 37"/>
           <p:cNvSpPr txBox="1"/>
           <p:nvPr/>
         </p:nvSpPr>
@@ -9057,7 +9023,7 @@
       </p:sp>
       <p:sp>
         <p:nvSpPr>
-          <p:cNvPr id="40" name="TextBox 39"/>
+          <p:cNvPr id="39" name="TextBox 38"/>
           <p:cNvSpPr txBox="1"/>
           <p:nvPr/>
         </p:nvSpPr>
@@ -9091,7 +9057,7 @@
       </p:sp>
       <p:sp>
         <p:nvSpPr>
-          <p:cNvPr id="41" name="TextBox 40"/>
+          <p:cNvPr id="40" name="TextBox 39"/>
           <p:cNvSpPr txBox="1"/>
           <p:nvPr/>
         </p:nvSpPr>
@@ -9125,7 +9091,7 @@
       </p:sp>
       <p:sp>
         <p:nvSpPr>
-          <p:cNvPr id="42" name="Rectangle 41"/>
+          <p:cNvPr id="41" name="Rectangle 40"/>
           <p:cNvSpPr/>
           <p:nvPr/>
         </p:nvSpPr>
@@ -9171,7 +9137,7 @@
       </p:sp>
       <p:sp>
         <p:nvSpPr>
-          <p:cNvPr id="43" name="Rectangle 42"/>
+          <p:cNvPr id="42" name="Rectangle 41"/>
           <p:cNvSpPr/>
           <p:nvPr/>
         </p:nvSpPr>
@@ -9215,7 +9181,7 @@
       </p:sp>
       <p:sp>
         <p:nvSpPr>
-          <p:cNvPr id="44" name="TextBox 43"/>
+          <p:cNvPr id="43" name="TextBox 42"/>
           <p:cNvSpPr txBox="1"/>
           <p:nvPr/>
         </p:nvSpPr>
@@ -9250,7 +9216,7 @@
       </p:sp>
       <p:sp>
         <p:nvSpPr>
-          <p:cNvPr id="45" name="TextBox 44"/>
+          <p:cNvPr id="44" name="TextBox 43"/>
           <p:cNvSpPr txBox="1"/>
           <p:nvPr/>
         </p:nvSpPr>
@@ -9284,7 +9250,7 @@
       </p:sp>
       <p:sp>
         <p:nvSpPr>
-          <p:cNvPr id="46" name="TextBox 45"/>
+          <p:cNvPr id="45" name="TextBox 44"/>
           <p:cNvSpPr txBox="1"/>
           <p:nvPr/>
         </p:nvSpPr>
@@ -9318,7 +9284,7 @@
       </p:sp>
       <p:sp>
         <p:nvSpPr>
-          <p:cNvPr id="47" name="TextBox 46"/>
+          <p:cNvPr id="46" name="TextBox 45"/>
           <p:cNvSpPr txBox="1"/>
           <p:nvPr/>
         </p:nvSpPr>
@@ -9352,7 +9318,7 @@
       </p:sp>
       <p:sp>
         <p:nvSpPr>
-          <p:cNvPr id="48" name="TextBox 47"/>
+          <p:cNvPr id="47" name="TextBox 46"/>
           <p:cNvSpPr txBox="1"/>
           <p:nvPr/>
         </p:nvSpPr>
@@ -9387,7 +9353,7 @@
       </p:sp>
       <p:cxnSp>
         <p:nvCxnSpPr>
-          <p:cNvPr id="49" name="Connector 48"/>
+          <p:cNvPr id="48" name="Connector 47"/>
           <p:cNvCxnSpPr/>
           <p:nvPr/>
         </p:nvCxnSpPr>
@@ -9422,7 +9388,7 @@
       </p:cxnSp>
       <p:sp>
         <p:nvSpPr>
-          <p:cNvPr id="50" name="TextBox 49"/>
+          <p:cNvPr id="49" name="TextBox 48"/>
           <p:cNvSpPr txBox="1"/>
           <p:nvPr/>
         </p:nvSpPr>
@@ -9457,7 +9423,7 @@
       </p:sp>
       <p:sp>
         <p:nvSpPr>
-          <p:cNvPr id="51" name="TextBox 50"/>
+          <p:cNvPr id="50" name="TextBox 49"/>
           <p:cNvSpPr txBox="1"/>
           <p:nvPr/>
         </p:nvSpPr>
@@ -9492,7 +9458,7 @@
       </p:sp>
       <p:sp>
         <p:nvSpPr>
-          <p:cNvPr id="52" name="Rounded Rectangle 51"/>
+          <p:cNvPr id="51" name="Rounded Rectangle 50"/>
           <p:cNvSpPr/>
           <p:nvPr/>
         </p:nvSpPr>
@@ -9547,7 +9513,7 @@
       </p:sp>
       <p:cxnSp>
         <p:nvCxnSpPr>
-          <p:cNvPr id="53" name="Connector 52"/>
+          <p:cNvPr id="52" name="Connector 51"/>
           <p:cNvCxnSpPr/>
           <p:nvPr/>
         </p:nvCxnSpPr>
@@ -9582,7 +9548,7 @@
       </p:cxnSp>
       <p:sp>
         <p:nvSpPr>
-          <p:cNvPr id="54" name="TextBox 53"/>
+          <p:cNvPr id="53" name="TextBox 52"/>
           <p:cNvSpPr txBox="1"/>
           <p:nvPr/>
         </p:nvSpPr>
@@ -9617,7 +9583,7 @@
       </p:sp>
       <p:sp>
         <p:nvSpPr>
-          <p:cNvPr id="55" name="TextBox 54"/>
+          <p:cNvPr id="54" name="TextBox 53"/>
           <p:cNvSpPr txBox="1"/>
           <p:nvPr/>
         </p:nvSpPr>
@@ -9652,7 +9618,7 @@
       </p:sp>
       <p:sp>
         <p:nvSpPr>
-          <p:cNvPr id="56" name="Rounded Rectangle 55"/>
+          <p:cNvPr id="55" name="Rounded Rectangle 54"/>
           <p:cNvSpPr/>
           <p:nvPr/>
         </p:nvSpPr>
@@ -9707,7 +9673,7 @@
       </p:sp>
       <p:cxnSp>
         <p:nvCxnSpPr>
-          <p:cNvPr id="57" name="Connector 56"/>
+          <p:cNvPr id="56" name="Connector 55"/>
           <p:cNvCxnSpPr/>
           <p:nvPr/>
         </p:nvCxnSpPr>
@@ -9742,7 +9708,7 @@
       </p:cxnSp>
       <p:sp>
         <p:nvSpPr>
-          <p:cNvPr id="58" name="TextBox 57"/>
+          <p:cNvPr id="57" name="TextBox 56"/>
           <p:cNvSpPr txBox="1"/>
           <p:nvPr/>
         </p:nvSpPr>
@@ -9777,7 +9743,7 @@
       </p:sp>
       <p:sp>
         <p:nvSpPr>
-          <p:cNvPr id="59" name="TextBox 58"/>
+          <p:cNvPr id="58" name="TextBox 57"/>
           <p:cNvSpPr txBox="1"/>
           <p:nvPr/>
         </p:nvSpPr>
@@ -9812,7 +9778,7 @@
       </p:sp>
       <p:sp>
         <p:nvSpPr>
-          <p:cNvPr id="60" name="Rounded Rectangle 59"/>
+          <p:cNvPr id="59" name="Rounded Rectangle 58"/>
           <p:cNvSpPr/>
           <p:nvPr/>
         </p:nvSpPr>
@@ -9867,7 +9833,7 @@
       </p:sp>
       <p:cxnSp>
         <p:nvCxnSpPr>
-          <p:cNvPr id="61" name="Connector 60"/>
+          <p:cNvPr id="60" name="Connector 59"/>
           <p:cNvCxnSpPr/>
           <p:nvPr/>
         </p:nvCxnSpPr>
@@ -9902,7 +9868,7 @@
       </p:cxnSp>
       <p:sp>
         <p:nvSpPr>
-          <p:cNvPr id="62" name="TextBox 61"/>
+          <p:cNvPr id="61" name="TextBox 60"/>
           <p:cNvSpPr txBox="1"/>
           <p:nvPr/>
         </p:nvSpPr>
@@ -9937,7 +9903,7 @@
       </p:sp>
       <p:sp>
         <p:nvSpPr>
-          <p:cNvPr id="63" name="TextBox 62"/>
+          <p:cNvPr id="62" name="TextBox 61"/>
           <p:cNvSpPr txBox="1"/>
           <p:nvPr/>
         </p:nvSpPr>
@@ -9972,7 +9938,7 @@
       </p:sp>
       <p:sp>
         <p:nvSpPr>
-          <p:cNvPr id="64" name="Rounded Rectangle 63"/>
+          <p:cNvPr id="63" name="Rounded Rectangle 62"/>
           <p:cNvSpPr/>
           <p:nvPr/>
         </p:nvSpPr>
@@ -10027,7 +9993,7 @@
       </p:sp>
       <p:cxnSp>
         <p:nvCxnSpPr>
-          <p:cNvPr id="65" name="Connector 64"/>
+          <p:cNvPr id="64" name="Connector 63"/>
           <p:cNvCxnSpPr/>
           <p:nvPr/>
         </p:nvCxnSpPr>
@@ -10062,7 +10028,7 @@
       </p:cxnSp>
       <p:sp>
         <p:nvSpPr>
-          <p:cNvPr id="66" name="TextBox 65"/>
+          <p:cNvPr id="65" name="TextBox 64"/>
           <p:cNvSpPr txBox="1"/>
           <p:nvPr/>
         </p:nvSpPr>
@@ -10097,7 +10063,7 @@
       </p:sp>
       <p:sp>
         <p:nvSpPr>
-          <p:cNvPr id="67" name="TextBox 66"/>
+          <p:cNvPr id="66" name="TextBox 65"/>
           <p:cNvSpPr txBox="1"/>
           <p:nvPr/>
         </p:nvSpPr>
@@ -10132,7 +10098,7 @@
       </p:sp>
       <p:sp>
         <p:nvSpPr>
-          <p:cNvPr id="68" name="Rounded Rectangle 67"/>
+          <p:cNvPr id="67" name="Rounded Rectangle 66"/>
           <p:cNvSpPr/>
           <p:nvPr/>
         </p:nvSpPr>
@@ -10187,7 +10153,7 @@
       </p:sp>
       <p:cxnSp>
         <p:nvCxnSpPr>
-          <p:cNvPr id="69" name="Connector 68"/>
+          <p:cNvPr id="68" name="Connector 67"/>
           <p:cNvCxnSpPr/>
           <p:nvPr/>
         </p:nvCxnSpPr>
@@ -10222,7 +10188,7 @@
       </p:cxnSp>
       <p:sp>
         <p:nvSpPr>
-          <p:cNvPr id="70" name="TextBox 69"/>
+          <p:cNvPr id="69" name="TextBox 68"/>
           <p:cNvSpPr txBox="1"/>
           <p:nvPr/>
         </p:nvSpPr>
@@ -10257,7 +10223,7 @@
       </p:sp>
       <p:sp>
         <p:nvSpPr>
-          <p:cNvPr id="71" name="TextBox 70"/>
+          <p:cNvPr id="70" name="TextBox 69"/>
           <p:cNvSpPr txBox="1"/>
           <p:nvPr/>
         </p:nvSpPr>
@@ -10292,7 +10258,7 @@
       </p:sp>
       <p:sp>
         <p:nvSpPr>
-          <p:cNvPr id="72" name="Rounded Rectangle 71"/>
+          <p:cNvPr id="71" name="Rounded Rectangle 70"/>
           <p:cNvSpPr/>
           <p:nvPr/>
         </p:nvSpPr>
@@ -10347,7 +10313,7 @@
       </p:sp>
       <p:cxnSp>
         <p:nvCxnSpPr>
-          <p:cNvPr id="73" name="Connector 72"/>
+          <p:cNvPr id="72" name="Connector 71"/>
           <p:cNvCxnSpPr/>
           <p:nvPr/>
         </p:nvCxnSpPr>
@@ -10382,7 +10348,7 @@
       </p:cxnSp>
       <p:sp>
         <p:nvSpPr>
-          <p:cNvPr id="74" name="TextBox 73"/>
+          <p:cNvPr id="73" name="TextBox 72"/>
           <p:cNvSpPr txBox="1"/>
           <p:nvPr/>
         </p:nvSpPr>
@@ -10417,7 +10383,7 @@
       </p:sp>
       <p:sp>
         <p:nvSpPr>
-          <p:cNvPr id="75" name="TextBox 74"/>
+          <p:cNvPr id="74" name="TextBox 73"/>
           <p:cNvSpPr txBox="1"/>
           <p:nvPr/>
         </p:nvSpPr>
@@ -10452,7 +10418,7 @@
       </p:sp>
       <p:sp>
         <p:nvSpPr>
-          <p:cNvPr id="76" name="Rounded Rectangle 75"/>
+          <p:cNvPr id="75" name="Rounded Rectangle 74"/>
           <p:cNvSpPr/>
           <p:nvPr/>
         </p:nvSpPr>
@@ -10507,7 +10473,7 @@
       </p:sp>
       <p:cxnSp>
         <p:nvCxnSpPr>
-          <p:cNvPr id="77" name="Connector 76"/>
+          <p:cNvPr id="76" name="Connector 75"/>
           <p:cNvCxnSpPr/>
           <p:nvPr/>
         </p:nvCxnSpPr>
@@ -10542,7 +10508,7 @@
       </p:cxnSp>
       <p:sp>
         <p:nvSpPr>
-          <p:cNvPr id="78" name="TextBox 77"/>
+          <p:cNvPr id="77" name="TextBox 76"/>
           <p:cNvSpPr txBox="1"/>
           <p:nvPr/>
         </p:nvSpPr>
@@ -10577,7 +10543,7 @@
       </p:sp>
       <p:sp>
         <p:nvSpPr>
-          <p:cNvPr id="79" name="TextBox 78"/>
+          <p:cNvPr id="78" name="TextBox 77"/>
           <p:cNvSpPr txBox="1"/>
           <p:nvPr/>
         </p:nvSpPr>
@@ -10612,7 +10578,7 @@
       </p:sp>
       <p:sp>
         <p:nvSpPr>
-          <p:cNvPr id="80" name="Rounded Rectangle 79"/>
+          <p:cNvPr id="79" name="Rounded Rectangle 78"/>
           <p:cNvSpPr/>
           <p:nvPr/>
         </p:nvSpPr>
@@ -10667,7 +10633,7 @@
       </p:sp>
       <p:sp>
         <p:nvSpPr>
-          <p:cNvPr id="81" name="Rounded Rectangle 80"/>
+          <p:cNvPr id="80" name="Rounded Rectangle 79"/>
           <p:cNvSpPr/>
           <p:nvPr/>
         </p:nvSpPr>
@@ -10713,7 +10679,7 @@
       </p:sp>
       <p:sp>
         <p:nvSpPr>
-          <p:cNvPr id="82" name="TextBox 81"/>
+          <p:cNvPr id="81" name="TextBox 80"/>
           <p:cNvSpPr txBox="1"/>
           <p:nvPr/>
         </p:nvSpPr>
@@ -10741,14 +10707,14 @@
                 </a:solidFill>
                 <a:latin typeface="Segoe UI"/>
               </a:rPr>
-              <a:t>Notation Merise : (min,max) — 0,n = zéro à plusieurs · 1,1 = un et un seul  |  Ce MCD reste stable même si le modèle physique (page 1) regroupe erreurs/pannes/maintenances dans une table de faits unifiée pour la performance analytique</a:t>
-            </a:r>
-          </a:p>
-        </p:txBody>
-      </p:sp>
-      <p:sp>
-        <p:nvSpPr>
-          <p:cNvPr id="83" name="TextBox 82"/>
+              <a:t>Notation Merise : (min,max) — 0,n = zéro à plusieurs · 1,1 = un et un seul  |  Ce MCD reste stable même si le modèle physique (page 3) regroupe erreurs/pannes/maintenances dans une table de faits unifiée pour la performance analytique</a:t>
+            </a:r>
+          </a:p>
+        </p:txBody>
+      </p:sp>
+      <p:sp>
+        <p:nvSpPr>
+          <p:cNvPr id="82" name="TextBox 81"/>
           <p:cNvSpPr txBox="1"/>
           <p:nvPr/>
         </p:nvSpPr>
@@ -10783,7 +10749,2225 @@
       </p:sp>
       <p:sp>
         <p:nvSpPr>
-          <p:cNvPr id="84" name="Rounded Rectangle 83"/>
+          <p:cNvPr id="83" name="Rounded Rectangle 82"/>
+          <p:cNvSpPr/>
+          <p:nvPr/>
+        </p:nvSpPr>
+        <p:spPr>
+          <a:xfrm>
+            <a:off x="10104120" y="6419088"/>
+            <a:ext cx="1737360" cy="310896"/>
+          </a:xfrm>
+          <a:prstGeom prst="roundRect">
+            <a:avLst>
+              <a:gd name="adj" fmla="val 50000"/>
+            </a:avLst>
+          </a:prstGeom>
+          <a:solidFill>
+            <a:srgbClr val="E9F3FB"/>
+          </a:solidFill>
+          <a:ln>
+            <a:noFill/>
+          </a:ln>
+          <a:effectLst/>
+        </p:spPr>
+        <p:style>
+          <a:lnRef idx="1">
+            <a:schemeClr val="accent1"/>
+          </a:lnRef>
+          <a:fillRef idx="3">
+            <a:schemeClr val="accent1"/>
+          </a:fillRef>
+          <a:effectRef idx="2">
+            <a:schemeClr val="accent1"/>
+          </a:effectRef>
+          <a:fontRef idx="minor">
+            <a:schemeClr val="lt1"/>
+          </a:fontRef>
+        </p:style>
+        <p:txBody>
+          <a:bodyPr rtlCol="0" anchor="ctr" lIns="50800" rIns="50800" tIns="0" bIns="0" wrap="square"/>
+          <a:lstStyle/>
+          <a:p>
+            <a:pPr algn="ctr"/>
+            <a:r>
+              <a:rPr sz="950" b="1" i="0">
+                <a:solidFill>
+                  <a:srgbClr val="0B2947"/>
+                </a:solidFill>
+                <a:latin typeface="Segoe UI"/>
+              </a:rPr>
+              <a:t>AutoMeca Systems</a:t>
+            </a:r>
+          </a:p>
+        </p:txBody>
+      </p:sp>
+    </p:spTree>
+  </p:cSld>
+  <p:clrMapOvr>
+    <a:masterClrMapping/>
+  </p:clrMapOvr>
+</p:sld>
+</file>
+
+<file path=ppt/slides/slide3.xml><?xml version="1.0" encoding="utf-8"?>
+<p:sld xmlns:a="http://schemas.openxmlformats.org/drawingml/2006/main" xmlns:p="http://schemas.openxmlformats.org/presentationml/2006/main" xmlns:r="http://schemas.openxmlformats.org/officeDocument/2006/relationships">
+  <p:cSld>
+    <p:bg>
+      <p:bgPr>
+        <a:solidFill>
+          <a:srgbClr val="FFFFFF"/>
+        </a:solidFill>
+        <a:effectLst/>
+      </p:bgPr>
+    </p:bg>
+    <p:spTree>
+      <p:nvGrpSpPr>
+        <p:cNvPr id="1" name=""/>
+        <p:cNvGrpSpPr/>
+        <p:nvPr/>
+      </p:nvGrpSpPr>
+      <p:grpSpPr/>
+      <p:sp>
+        <p:nvSpPr>
+          <p:cNvPr id="2" name="Rectangle 1"/>
+          <p:cNvSpPr/>
+          <p:nvPr/>
+        </p:nvSpPr>
+        <p:spPr>
+          <a:xfrm>
+            <a:off x="0" y="0"/>
+            <a:ext cx="12191695" cy="932688"/>
+          </a:xfrm>
+          <a:prstGeom prst="rect">
+            <a:avLst/>
+          </a:prstGeom>
+          <a:solidFill>
+            <a:srgbClr val="0B2947"/>
+          </a:solidFill>
+          <a:ln>
+            <a:noFill/>
+          </a:ln>
+          <a:effectLst/>
+        </p:spPr>
+        <p:style>
+          <a:lnRef idx="1">
+            <a:schemeClr val="accent1"/>
+          </a:lnRef>
+          <a:fillRef idx="3">
+            <a:schemeClr val="accent1"/>
+          </a:fillRef>
+          <a:effectRef idx="2">
+            <a:schemeClr val="accent1"/>
+          </a:effectRef>
+          <a:fontRef idx="minor">
+            <a:schemeClr val="lt1"/>
+          </a:fontRef>
+        </p:style>
+        <p:txBody>
+          <a:bodyPr rtlCol="0" anchor="ctr"/>
+          <a:lstStyle/>
+          <a:p>
+            <a:pPr algn="ctr"/>
+          </a:p>
+        </p:txBody>
+      </p:sp>
+      <p:sp>
+        <p:nvSpPr>
+          <p:cNvPr id="3" name="TextBox 2"/>
+          <p:cNvSpPr txBox="1"/>
+          <p:nvPr/>
+        </p:nvSpPr>
+        <p:spPr>
+          <a:xfrm>
+            <a:off x="457200" y="109728"/>
+            <a:ext cx="11247120" cy="411480"/>
+          </a:xfrm>
+          <a:prstGeom prst="rect">
+            <a:avLst/>
+          </a:prstGeom>
+          <a:noFill/>
+        </p:spPr>
+        <p:txBody>
+          <a:bodyPr wrap="square" lIns="0" rIns="0" tIns="0" bIns="0">
+            <a:spAutoFit/>
+          </a:bodyPr>
+          <a:lstStyle/>
+          <a:p>
+            <a:pPr algn="l"/>
+            <a:r>
+              <a:rPr sz="2100" b="1" i="0">
+                <a:solidFill>
+                  <a:srgbClr val="FFFFFF"/>
+                </a:solidFill>
+                <a:latin typeface="Segoe UI"/>
+              </a:rPr>
+              <a:t>Schéma en étoile — modèle physique (PostgreSQL)</a:t>
+            </a:r>
+          </a:p>
+        </p:txBody>
+      </p:sp>
+      <p:sp>
+        <p:nvSpPr>
+          <p:cNvPr id="4" name="TextBox 3"/>
+          <p:cNvSpPr txBox="1"/>
+          <p:nvPr/>
+        </p:nvSpPr>
+        <p:spPr>
+          <a:xfrm>
+            <a:off x="457200" y="530352"/>
+            <a:ext cx="11247120" cy="320040"/>
+          </a:xfrm>
+          <a:prstGeom prst="rect">
+            <a:avLst/>
+          </a:prstGeom>
+          <a:noFill/>
+        </p:spPr>
+        <p:txBody>
+          <a:bodyPr wrap="square" lIns="0" rIns="0" tIns="0" bIns="0">
+            <a:spAutoFit/>
+          </a:bodyPr>
+          <a:lstStyle/>
+          <a:p>
+            <a:pPr algn="l"/>
+            <a:r>
+              <a:rPr sz="1150" b="0" i="1">
+                <a:solidFill>
+                  <a:srgbClr val="F5C344"/>
+                </a:solidFill>
+                <a:latin typeface="Segoe UI"/>
+              </a:rPr>
+              <a:t>Bloc 2 — AutoMeca Systems — table de faits unifiée entourée de ses dimensions (schéma `datamart`)</a:t>
+            </a:r>
+          </a:p>
+        </p:txBody>
+      </p:sp>
+      <p:sp>
+        <p:nvSpPr>
+          <p:cNvPr id="5" name="Rectangle 4"/>
+          <p:cNvSpPr/>
+          <p:nvPr/>
+        </p:nvSpPr>
+        <p:spPr>
+          <a:xfrm>
+            <a:off x="4846320" y="2706624"/>
+            <a:ext cx="2468880" cy="1993392"/>
+          </a:xfrm>
+          <a:prstGeom prst="rect">
+            <a:avLst/>
+          </a:prstGeom>
+          <a:solidFill>
+            <a:srgbClr val="FFFFFF"/>
+          </a:solidFill>
+          <a:ln w="16510">
+            <a:solidFill>
+              <a:srgbClr val="0B2947"/>
+            </a:solidFill>
+          </a:ln>
+          <a:effectLst/>
+        </p:spPr>
+        <p:style>
+          <a:lnRef idx="1">
+            <a:schemeClr val="accent1"/>
+          </a:lnRef>
+          <a:fillRef idx="3">
+            <a:schemeClr val="accent1"/>
+          </a:fillRef>
+          <a:effectRef idx="2">
+            <a:schemeClr val="accent1"/>
+          </a:effectRef>
+          <a:fontRef idx="minor">
+            <a:schemeClr val="lt1"/>
+          </a:fontRef>
+        </p:style>
+        <p:txBody>
+          <a:bodyPr rtlCol="0" anchor="ctr"/>
+          <a:lstStyle/>
+          <a:p>
+            <a:pPr algn="ctr"/>
+          </a:p>
+        </p:txBody>
+      </p:sp>
+      <p:sp>
+        <p:nvSpPr>
+          <p:cNvPr id="6" name="Rectangle 5"/>
+          <p:cNvSpPr/>
+          <p:nvPr/>
+        </p:nvSpPr>
+        <p:spPr>
+          <a:xfrm>
+            <a:off x="4846320" y="2706624"/>
+            <a:ext cx="2468880" cy="292608"/>
+          </a:xfrm>
+          <a:prstGeom prst="rect">
+            <a:avLst/>
+          </a:prstGeom>
+          <a:solidFill>
+            <a:srgbClr val="0A66C2"/>
+          </a:solidFill>
+          <a:ln>
+            <a:noFill/>
+          </a:ln>
+          <a:effectLst/>
+        </p:spPr>
+        <p:style>
+          <a:lnRef idx="1">
+            <a:schemeClr val="accent1"/>
+          </a:lnRef>
+          <a:fillRef idx="3">
+            <a:schemeClr val="accent1"/>
+          </a:fillRef>
+          <a:effectRef idx="2">
+            <a:schemeClr val="accent1"/>
+          </a:effectRef>
+          <a:fontRef idx="minor">
+            <a:schemeClr val="lt1"/>
+          </a:fontRef>
+        </p:style>
+        <p:txBody>
+          <a:bodyPr rtlCol="0" anchor="ctr"/>
+          <a:lstStyle/>
+          <a:p>
+            <a:pPr algn="ctr"/>
+          </a:p>
+        </p:txBody>
+      </p:sp>
+      <p:sp>
+        <p:nvSpPr>
+          <p:cNvPr id="7" name="TextBox 6"/>
+          <p:cNvSpPr txBox="1"/>
+          <p:nvPr/>
+        </p:nvSpPr>
+        <p:spPr>
+          <a:xfrm>
+            <a:off x="4937760" y="2706624"/>
+            <a:ext cx="2286000" cy="292608"/>
+          </a:xfrm>
+          <a:prstGeom prst="rect">
+            <a:avLst/>
+          </a:prstGeom>
+          <a:noFill/>
+        </p:spPr>
+        <p:txBody>
+          <a:bodyPr wrap="square" lIns="0" rIns="0" tIns="0" bIns="0" anchor="ctr">
+            <a:spAutoFit/>
+          </a:bodyPr>
+          <a:lstStyle/>
+          <a:p>
+            <a:pPr algn="l"/>
+            <a:r>
+              <a:rPr sz="1150" b="1" i="0">
+                <a:solidFill>
+                  <a:srgbClr val="FFFFFF"/>
+                </a:solidFill>
+                <a:latin typeface="Segoe UI"/>
+              </a:rPr>
+              <a:t>FAIT_EVENEMENT</a:t>
+            </a:r>
+          </a:p>
+        </p:txBody>
+      </p:sp>
+      <p:sp>
+        <p:nvSpPr>
+          <p:cNvPr id="8" name="TextBox 7"/>
+          <p:cNvSpPr txBox="1"/>
+          <p:nvPr/>
+        </p:nvSpPr>
+        <p:spPr>
+          <a:xfrm>
+            <a:off x="4974336" y="3044951"/>
+            <a:ext cx="2212848" cy="201168"/>
+          </a:xfrm>
+          <a:prstGeom prst="rect">
+            <a:avLst/>
+          </a:prstGeom>
+          <a:noFill/>
+        </p:spPr>
+        <p:txBody>
+          <a:bodyPr wrap="square" lIns="0" rIns="0" tIns="0" bIns="0">
+            <a:spAutoFit/>
+          </a:bodyPr>
+          <a:lstStyle/>
+          <a:p>
+            <a:r>
+              <a:rPr sz="900" b="0" i="0" u="sng">
+                <a:solidFill>
+                  <a:srgbClr val="22303F"/>
+                </a:solidFill>
+                <a:latin typeface="Segoe UI"/>
+              </a:rPr>
+              <a:t>id_evenement (id)</a:t>
+            </a:r>
+          </a:p>
+        </p:txBody>
+      </p:sp>
+      <p:sp>
+        <p:nvSpPr>
+          <p:cNvPr id="9" name="TextBox 8"/>
+          <p:cNvSpPr txBox="1"/>
+          <p:nvPr/>
+        </p:nvSpPr>
+        <p:spPr>
+          <a:xfrm>
+            <a:off x="4974336" y="3246120"/>
+            <a:ext cx="2212848" cy="201168"/>
+          </a:xfrm>
+          <a:prstGeom prst="rect">
+            <a:avLst/>
+          </a:prstGeom>
+          <a:noFill/>
+        </p:spPr>
+        <p:txBody>
+          <a:bodyPr wrap="square" lIns="0" rIns="0" tIns="0" bIns="0">
+            <a:spAutoFit/>
+          </a:bodyPr>
+          <a:lstStyle/>
+          <a:p>
+            <a:r>
+              <a:rPr sz="900" b="0" i="0">
+                <a:solidFill>
+                  <a:srgbClr val="22303F"/>
+                </a:solidFill>
+                <a:latin typeface="Segoe UI"/>
+              </a:rPr>
+              <a:t>id_date</a:t>
+            </a:r>
+          </a:p>
+        </p:txBody>
+      </p:sp>
+      <p:sp>
+        <p:nvSpPr>
+          <p:cNvPr id="10" name="TextBox 9"/>
+          <p:cNvSpPr txBox="1"/>
+          <p:nvPr/>
+        </p:nvSpPr>
+        <p:spPr>
+          <a:xfrm>
+            <a:off x="4974336" y="3447287"/>
+            <a:ext cx="2212848" cy="201168"/>
+          </a:xfrm>
+          <a:prstGeom prst="rect">
+            <a:avLst/>
+          </a:prstGeom>
+          <a:noFill/>
+        </p:spPr>
+        <p:txBody>
+          <a:bodyPr wrap="square" lIns="0" rIns="0" tIns="0" bIns="0">
+            <a:spAutoFit/>
+          </a:bodyPr>
+          <a:lstStyle/>
+          <a:p>
+            <a:r>
+              <a:rPr sz="900" b="0" i="0">
+                <a:solidFill>
+                  <a:srgbClr val="22303F"/>
+                </a:solidFill>
+                <a:latin typeface="Segoe UI"/>
+              </a:rPr>
+              <a:t>datetime_evt</a:t>
+            </a:r>
+          </a:p>
+        </p:txBody>
+      </p:sp>
+      <p:sp>
+        <p:nvSpPr>
+          <p:cNvPr id="11" name="TextBox 10"/>
+          <p:cNvSpPr txBox="1"/>
+          <p:nvPr/>
+        </p:nvSpPr>
+        <p:spPr>
+          <a:xfrm>
+            <a:off x="4974336" y="3648456"/>
+            <a:ext cx="2212848" cy="201168"/>
+          </a:xfrm>
+          <a:prstGeom prst="rect">
+            <a:avLst/>
+          </a:prstGeom>
+          <a:noFill/>
+        </p:spPr>
+        <p:txBody>
+          <a:bodyPr wrap="square" lIns="0" rIns="0" tIns="0" bIns="0">
+            <a:spAutoFit/>
+          </a:bodyPr>
+          <a:lstStyle/>
+          <a:p>
+            <a:r>
+              <a:rPr sz="900" b="0" i="0">
+                <a:solidFill>
+                  <a:srgbClr val="22303F"/>
+                </a:solidFill>
+                <a:latin typeface="Segoe UI"/>
+              </a:rPr>
+              <a:t>id_machine</a:t>
+            </a:r>
+          </a:p>
+        </p:txBody>
+      </p:sp>
+      <p:sp>
+        <p:nvSpPr>
+          <p:cNvPr id="12" name="TextBox 11"/>
+          <p:cNvSpPr txBox="1"/>
+          <p:nvPr/>
+        </p:nvSpPr>
+        <p:spPr>
+          <a:xfrm>
+            <a:off x="4974336" y="3849624"/>
+            <a:ext cx="2212848" cy="201168"/>
+          </a:xfrm>
+          <a:prstGeom prst="rect">
+            <a:avLst/>
+          </a:prstGeom>
+          <a:noFill/>
+        </p:spPr>
+        <p:txBody>
+          <a:bodyPr wrap="square" lIns="0" rIns="0" tIns="0" bIns="0">
+            <a:spAutoFit/>
+          </a:bodyPr>
+          <a:lstStyle/>
+          <a:p>
+            <a:r>
+              <a:rPr sz="900" b="0" i="0">
+                <a:solidFill>
+                  <a:srgbClr val="22303F"/>
+                </a:solidFill>
+                <a:latin typeface="Segoe UI"/>
+              </a:rPr>
+              <a:t>id_type_evenement</a:t>
+            </a:r>
+          </a:p>
+        </p:txBody>
+      </p:sp>
+      <p:sp>
+        <p:nvSpPr>
+          <p:cNvPr id="13" name="TextBox 12"/>
+          <p:cNvSpPr txBox="1"/>
+          <p:nvPr/>
+        </p:nvSpPr>
+        <p:spPr>
+          <a:xfrm>
+            <a:off x="4974336" y="4050791"/>
+            <a:ext cx="2212848" cy="201168"/>
+          </a:xfrm>
+          <a:prstGeom prst="rect">
+            <a:avLst/>
+          </a:prstGeom>
+          <a:noFill/>
+        </p:spPr>
+        <p:txBody>
+          <a:bodyPr wrap="square" lIns="0" rIns="0" tIns="0" bIns="0">
+            <a:spAutoFit/>
+          </a:bodyPr>
+          <a:lstStyle/>
+          <a:p>
+            <a:r>
+              <a:rPr sz="900" b="0" i="0">
+                <a:solidFill>
+                  <a:srgbClr val="22303F"/>
+                </a:solidFill>
+                <a:latin typeface="Segoe UI"/>
+              </a:rPr>
+              <a:t>id_code</a:t>
+            </a:r>
+          </a:p>
+        </p:txBody>
+      </p:sp>
+      <p:sp>
+        <p:nvSpPr>
+          <p:cNvPr id="14" name="TextBox 13"/>
+          <p:cNvSpPr txBox="1"/>
+          <p:nvPr/>
+        </p:nvSpPr>
+        <p:spPr>
+          <a:xfrm>
+            <a:off x="4974336" y="4251959"/>
+            <a:ext cx="2212848" cy="201168"/>
+          </a:xfrm>
+          <a:prstGeom prst="rect">
+            <a:avLst/>
+          </a:prstGeom>
+          <a:noFill/>
+        </p:spPr>
+        <p:txBody>
+          <a:bodyPr wrap="square" lIns="0" rIns="0" tIns="0" bIns="0">
+            <a:spAutoFit/>
+          </a:bodyPr>
+          <a:lstStyle/>
+          <a:p>
+            <a:r>
+              <a:rPr sz="900" b="0" i="0">
+                <a:solidFill>
+                  <a:srgbClr val="22303F"/>
+                </a:solidFill>
+                <a:latin typeface="Segoe UI"/>
+              </a:rPr>
+              <a:t>id_operateur (null)</a:t>
+            </a:r>
+          </a:p>
+        </p:txBody>
+      </p:sp>
+      <p:sp>
+        <p:nvSpPr>
+          <p:cNvPr id="15" name="TextBox 14"/>
+          <p:cNvSpPr txBox="1"/>
+          <p:nvPr/>
+        </p:nvSpPr>
+        <p:spPr>
+          <a:xfrm>
+            <a:off x="4974336" y="4453127"/>
+            <a:ext cx="2212848" cy="201168"/>
+          </a:xfrm>
+          <a:prstGeom prst="rect">
+            <a:avLst/>
+          </a:prstGeom>
+          <a:noFill/>
+        </p:spPr>
+        <p:txBody>
+          <a:bodyPr wrap="square" lIns="0" rIns="0" tIns="0" bIns="0">
+            <a:spAutoFit/>
+          </a:bodyPr>
+          <a:lstStyle/>
+          <a:p>
+            <a:r>
+              <a:rPr sz="900" b="0" i="0">
+                <a:solidFill>
+                  <a:srgbClr val="22303F"/>
+                </a:solidFill>
+                <a:latin typeface="Segoe UI"/>
+              </a:rPr>
+              <a:t>source_fichier</a:t>
+            </a:r>
+          </a:p>
+        </p:txBody>
+      </p:sp>
+      <p:sp>
+        <p:nvSpPr>
+          <p:cNvPr id="16" name="Rectangle 15"/>
+          <p:cNvSpPr/>
+          <p:nvPr/>
+        </p:nvSpPr>
+        <p:spPr>
+          <a:xfrm>
+            <a:off x="5029200" y="1097280"/>
+            <a:ext cx="2103120" cy="987552"/>
+          </a:xfrm>
+          <a:prstGeom prst="rect">
+            <a:avLst/>
+          </a:prstGeom>
+          <a:solidFill>
+            <a:srgbClr val="FFFFFF"/>
+          </a:solidFill>
+          <a:ln w="16510">
+            <a:solidFill>
+              <a:srgbClr val="0B2947"/>
+            </a:solidFill>
+          </a:ln>
+          <a:effectLst/>
+        </p:spPr>
+        <p:style>
+          <a:lnRef idx="1">
+            <a:schemeClr val="accent1"/>
+          </a:lnRef>
+          <a:fillRef idx="3">
+            <a:schemeClr val="accent1"/>
+          </a:fillRef>
+          <a:effectRef idx="2">
+            <a:schemeClr val="accent1"/>
+          </a:effectRef>
+          <a:fontRef idx="minor">
+            <a:schemeClr val="lt1"/>
+          </a:fontRef>
+        </p:style>
+        <p:txBody>
+          <a:bodyPr rtlCol="0" anchor="ctr"/>
+          <a:lstStyle/>
+          <a:p>
+            <a:pPr algn="ctr"/>
+          </a:p>
+        </p:txBody>
+      </p:sp>
+      <p:sp>
+        <p:nvSpPr>
+          <p:cNvPr id="17" name="Rectangle 16"/>
+          <p:cNvSpPr/>
+          <p:nvPr/>
+        </p:nvSpPr>
+        <p:spPr>
+          <a:xfrm>
+            <a:off x="5029200" y="1097280"/>
+            <a:ext cx="2103120" cy="292608"/>
+          </a:xfrm>
+          <a:prstGeom prst="rect">
+            <a:avLst/>
+          </a:prstGeom>
+          <a:solidFill>
+            <a:srgbClr val="0B2947"/>
+          </a:solidFill>
+          <a:ln>
+            <a:noFill/>
+          </a:ln>
+          <a:effectLst/>
+        </p:spPr>
+        <p:style>
+          <a:lnRef idx="1">
+            <a:schemeClr val="accent1"/>
+          </a:lnRef>
+          <a:fillRef idx="3">
+            <a:schemeClr val="accent1"/>
+          </a:fillRef>
+          <a:effectRef idx="2">
+            <a:schemeClr val="accent1"/>
+          </a:effectRef>
+          <a:fontRef idx="minor">
+            <a:schemeClr val="lt1"/>
+          </a:fontRef>
+        </p:style>
+        <p:txBody>
+          <a:bodyPr rtlCol="0" anchor="ctr"/>
+          <a:lstStyle/>
+          <a:p>
+            <a:pPr algn="ctr"/>
+          </a:p>
+        </p:txBody>
+      </p:sp>
+      <p:sp>
+        <p:nvSpPr>
+          <p:cNvPr id="18" name="TextBox 17"/>
+          <p:cNvSpPr txBox="1"/>
+          <p:nvPr/>
+        </p:nvSpPr>
+        <p:spPr>
+          <a:xfrm>
+            <a:off x="5120640" y="1097280"/>
+            <a:ext cx="1920239" cy="292608"/>
+          </a:xfrm>
+          <a:prstGeom prst="rect">
+            <a:avLst/>
+          </a:prstGeom>
+          <a:noFill/>
+        </p:spPr>
+        <p:txBody>
+          <a:bodyPr wrap="square" lIns="0" rIns="0" tIns="0" bIns="0" anchor="ctr">
+            <a:spAutoFit/>
+          </a:bodyPr>
+          <a:lstStyle/>
+          <a:p>
+            <a:pPr algn="l"/>
+            <a:r>
+              <a:rPr sz="1050" b="1" i="0">
+                <a:solidFill>
+                  <a:srgbClr val="FFFFFF"/>
+                </a:solidFill>
+                <a:latin typeface="Segoe UI"/>
+              </a:rPr>
+              <a:t>DIM_DATE</a:t>
+            </a:r>
+          </a:p>
+        </p:txBody>
+      </p:sp>
+      <p:sp>
+        <p:nvSpPr>
+          <p:cNvPr id="19" name="TextBox 18"/>
+          <p:cNvSpPr txBox="1"/>
+          <p:nvPr/>
+        </p:nvSpPr>
+        <p:spPr>
+          <a:xfrm>
+            <a:off x="5157216" y="1435608"/>
+            <a:ext cx="1847087" cy="201168"/>
+          </a:xfrm>
+          <a:prstGeom prst="rect">
+            <a:avLst/>
+          </a:prstGeom>
+          <a:noFill/>
+        </p:spPr>
+        <p:txBody>
+          <a:bodyPr wrap="square" lIns="0" rIns="0" tIns="0" bIns="0">
+            <a:spAutoFit/>
+          </a:bodyPr>
+          <a:lstStyle/>
+          <a:p>
+            <a:r>
+              <a:rPr sz="930" b="0" i="0" u="sng">
+                <a:solidFill>
+                  <a:srgbClr val="22303F"/>
+                </a:solidFill>
+                <a:latin typeface="Segoe UI"/>
+              </a:rPr>
+              <a:t>id_date (id)</a:t>
+            </a:r>
+          </a:p>
+        </p:txBody>
+      </p:sp>
+      <p:sp>
+        <p:nvSpPr>
+          <p:cNvPr id="20" name="TextBox 19"/>
+          <p:cNvSpPr txBox="1"/>
+          <p:nvPr/>
+        </p:nvSpPr>
+        <p:spPr>
+          <a:xfrm>
+            <a:off x="5157216" y="1636776"/>
+            <a:ext cx="1847087" cy="201168"/>
+          </a:xfrm>
+          <a:prstGeom prst="rect">
+            <a:avLst/>
+          </a:prstGeom>
+          <a:noFill/>
+        </p:spPr>
+        <p:txBody>
+          <a:bodyPr wrap="square" lIns="0" rIns="0" tIns="0" bIns="0">
+            <a:spAutoFit/>
+          </a:bodyPr>
+          <a:lstStyle/>
+          <a:p>
+            <a:r>
+              <a:rPr sz="930" b="0" i="0">
+                <a:solidFill>
+                  <a:srgbClr val="22303F"/>
+                </a:solidFill>
+                <a:latin typeface="Segoe UI"/>
+              </a:rPr>
+              <a:t>date_complete</a:t>
+            </a:r>
+          </a:p>
+        </p:txBody>
+      </p:sp>
+      <p:sp>
+        <p:nvSpPr>
+          <p:cNvPr id="21" name="TextBox 20"/>
+          <p:cNvSpPr txBox="1"/>
+          <p:nvPr/>
+        </p:nvSpPr>
+        <p:spPr>
+          <a:xfrm>
+            <a:off x="5157216" y="1837944"/>
+            <a:ext cx="1847087" cy="201168"/>
+          </a:xfrm>
+          <a:prstGeom prst="rect">
+            <a:avLst/>
+          </a:prstGeom>
+          <a:noFill/>
+        </p:spPr>
+        <p:txBody>
+          <a:bodyPr wrap="square" lIns="0" rIns="0" tIns="0" bIns="0">
+            <a:spAutoFit/>
+          </a:bodyPr>
+          <a:lstStyle/>
+          <a:p>
+            <a:r>
+              <a:rPr sz="930" b="0" i="0">
+                <a:solidFill>
+                  <a:srgbClr val="22303F"/>
+                </a:solidFill>
+                <a:latin typeface="Segoe UI"/>
+              </a:rPr>
+              <a:t>annee / mois / jour</a:t>
+            </a:r>
+          </a:p>
+        </p:txBody>
+      </p:sp>
+      <p:sp>
+        <p:nvSpPr>
+          <p:cNvPr id="22" name="Rectangle 21"/>
+          <p:cNvSpPr/>
+          <p:nvPr/>
+        </p:nvSpPr>
+        <p:spPr>
+          <a:xfrm>
+            <a:off x="8229600" y="3209544"/>
+            <a:ext cx="2103120" cy="987552"/>
+          </a:xfrm>
+          <a:prstGeom prst="rect">
+            <a:avLst/>
+          </a:prstGeom>
+          <a:solidFill>
+            <a:srgbClr val="FFFFFF"/>
+          </a:solidFill>
+          <a:ln w="16510">
+            <a:solidFill>
+              <a:srgbClr val="0B2947"/>
+            </a:solidFill>
+          </a:ln>
+          <a:effectLst/>
+        </p:spPr>
+        <p:style>
+          <a:lnRef idx="1">
+            <a:schemeClr val="accent1"/>
+          </a:lnRef>
+          <a:fillRef idx="3">
+            <a:schemeClr val="accent1"/>
+          </a:fillRef>
+          <a:effectRef idx="2">
+            <a:schemeClr val="accent1"/>
+          </a:effectRef>
+          <a:fontRef idx="minor">
+            <a:schemeClr val="lt1"/>
+          </a:fontRef>
+        </p:style>
+        <p:txBody>
+          <a:bodyPr rtlCol="0" anchor="ctr"/>
+          <a:lstStyle/>
+          <a:p>
+            <a:pPr algn="ctr"/>
+          </a:p>
+        </p:txBody>
+      </p:sp>
+      <p:sp>
+        <p:nvSpPr>
+          <p:cNvPr id="23" name="Rectangle 22"/>
+          <p:cNvSpPr/>
+          <p:nvPr/>
+        </p:nvSpPr>
+        <p:spPr>
+          <a:xfrm>
+            <a:off x="8229600" y="3209544"/>
+            <a:ext cx="2103120" cy="292608"/>
+          </a:xfrm>
+          <a:prstGeom prst="rect">
+            <a:avLst/>
+          </a:prstGeom>
+          <a:solidFill>
+            <a:srgbClr val="0B2947"/>
+          </a:solidFill>
+          <a:ln>
+            <a:noFill/>
+          </a:ln>
+          <a:effectLst/>
+        </p:spPr>
+        <p:style>
+          <a:lnRef idx="1">
+            <a:schemeClr val="accent1"/>
+          </a:lnRef>
+          <a:fillRef idx="3">
+            <a:schemeClr val="accent1"/>
+          </a:fillRef>
+          <a:effectRef idx="2">
+            <a:schemeClr val="accent1"/>
+          </a:effectRef>
+          <a:fontRef idx="minor">
+            <a:schemeClr val="lt1"/>
+          </a:fontRef>
+        </p:style>
+        <p:txBody>
+          <a:bodyPr rtlCol="0" anchor="ctr"/>
+          <a:lstStyle/>
+          <a:p>
+            <a:pPr algn="ctr"/>
+          </a:p>
+        </p:txBody>
+      </p:sp>
+      <p:sp>
+        <p:nvSpPr>
+          <p:cNvPr id="24" name="TextBox 23"/>
+          <p:cNvSpPr txBox="1"/>
+          <p:nvPr/>
+        </p:nvSpPr>
+        <p:spPr>
+          <a:xfrm>
+            <a:off x="8321040" y="3209544"/>
+            <a:ext cx="1920239" cy="292608"/>
+          </a:xfrm>
+          <a:prstGeom prst="rect">
+            <a:avLst/>
+          </a:prstGeom>
+          <a:noFill/>
+        </p:spPr>
+        <p:txBody>
+          <a:bodyPr wrap="square" lIns="0" rIns="0" tIns="0" bIns="0" anchor="ctr">
+            <a:spAutoFit/>
+          </a:bodyPr>
+          <a:lstStyle/>
+          <a:p>
+            <a:pPr algn="l"/>
+            <a:r>
+              <a:rPr sz="1050" b="1" i="0">
+                <a:solidFill>
+                  <a:srgbClr val="FFFFFF"/>
+                </a:solidFill>
+                <a:latin typeface="Segoe UI"/>
+              </a:rPr>
+              <a:t>DIM_MACHINE</a:t>
+            </a:r>
+          </a:p>
+        </p:txBody>
+      </p:sp>
+      <p:sp>
+        <p:nvSpPr>
+          <p:cNvPr id="25" name="TextBox 24"/>
+          <p:cNvSpPr txBox="1"/>
+          <p:nvPr/>
+        </p:nvSpPr>
+        <p:spPr>
+          <a:xfrm>
+            <a:off x="8357616" y="3547871"/>
+            <a:ext cx="1847087" cy="201168"/>
+          </a:xfrm>
+          <a:prstGeom prst="rect">
+            <a:avLst/>
+          </a:prstGeom>
+          <a:noFill/>
+        </p:spPr>
+        <p:txBody>
+          <a:bodyPr wrap="square" lIns="0" rIns="0" tIns="0" bIns="0">
+            <a:spAutoFit/>
+          </a:bodyPr>
+          <a:lstStyle/>
+          <a:p>
+            <a:r>
+              <a:rPr sz="930" b="0" i="0" u="sng">
+                <a:solidFill>
+                  <a:srgbClr val="22303F"/>
+                </a:solidFill>
+                <a:latin typeface="Segoe UI"/>
+              </a:rPr>
+              <a:t>id_machine (id)</a:t>
+            </a:r>
+          </a:p>
+        </p:txBody>
+      </p:sp>
+      <p:sp>
+        <p:nvSpPr>
+          <p:cNvPr id="26" name="TextBox 25"/>
+          <p:cNvSpPr txBox="1"/>
+          <p:nvPr/>
+        </p:nvSpPr>
+        <p:spPr>
+          <a:xfrm>
+            <a:off x="8357616" y="3749039"/>
+            <a:ext cx="1847087" cy="201168"/>
+          </a:xfrm>
+          <a:prstGeom prst="rect">
+            <a:avLst/>
+          </a:prstGeom>
+          <a:noFill/>
+        </p:spPr>
+        <p:txBody>
+          <a:bodyPr wrap="square" lIns="0" rIns="0" tIns="0" bIns="0">
+            <a:spAutoFit/>
+          </a:bodyPr>
+          <a:lstStyle/>
+          <a:p>
+            <a:r>
+              <a:rPr sz="930" b="0" i="0">
+                <a:solidFill>
+                  <a:srgbClr val="22303F"/>
+                </a:solidFill>
+                <a:latin typeface="Segoe UI"/>
+              </a:rPr>
+              <a:t>machine_id_nat</a:t>
+            </a:r>
+          </a:p>
+        </p:txBody>
+      </p:sp>
+      <p:sp>
+        <p:nvSpPr>
+          <p:cNvPr id="27" name="TextBox 26"/>
+          <p:cNvSpPr txBox="1"/>
+          <p:nvPr/>
+        </p:nvSpPr>
+        <p:spPr>
+          <a:xfrm>
+            <a:off x="8357616" y="3950207"/>
+            <a:ext cx="1847087" cy="201168"/>
+          </a:xfrm>
+          <a:prstGeom prst="rect">
+            <a:avLst/>
+          </a:prstGeom>
+          <a:noFill/>
+        </p:spPr>
+        <p:txBody>
+          <a:bodyPr wrap="square" lIns="0" rIns="0" tIns="0" bIns="0">
+            <a:spAutoFit/>
+          </a:bodyPr>
+          <a:lstStyle/>
+          <a:p>
+            <a:r>
+              <a:rPr sz="930" b="0" i="0">
+                <a:solidFill>
+                  <a:srgbClr val="22303F"/>
+                </a:solidFill>
+                <a:latin typeface="Segoe UI"/>
+              </a:rPr>
+              <a:t>model, age, tranche_age</a:t>
+            </a:r>
+          </a:p>
+        </p:txBody>
+      </p:sp>
+      <p:sp>
+        <p:nvSpPr>
+          <p:cNvPr id="28" name="Rectangle 27"/>
+          <p:cNvSpPr/>
+          <p:nvPr/>
+        </p:nvSpPr>
+        <p:spPr>
+          <a:xfrm>
+            <a:off x="8092440" y="5074920"/>
+            <a:ext cx="2103120" cy="987552"/>
+          </a:xfrm>
+          <a:prstGeom prst="rect">
+            <a:avLst/>
+          </a:prstGeom>
+          <a:solidFill>
+            <a:srgbClr val="FFFFFF"/>
+          </a:solidFill>
+          <a:ln w="16510">
+            <a:solidFill>
+              <a:srgbClr val="0B2947"/>
+            </a:solidFill>
+          </a:ln>
+          <a:effectLst/>
+        </p:spPr>
+        <p:style>
+          <a:lnRef idx="1">
+            <a:schemeClr val="accent1"/>
+          </a:lnRef>
+          <a:fillRef idx="3">
+            <a:schemeClr val="accent1"/>
+          </a:fillRef>
+          <a:effectRef idx="2">
+            <a:schemeClr val="accent1"/>
+          </a:effectRef>
+          <a:fontRef idx="minor">
+            <a:schemeClr val="lt1"/>
+          </a:fontRef>
+        </p:style>
+        <p:txBody>
+          <a:bodyPr rtlCol="0" anchor="ctr"/>
+          <a:lstStyle/>
+          <a:p>
+            <a:pPr algn="ctr"/>
+          </a:p>
+        </p:txBody>
+      </p:sp>
+      <p:sp>
+        <p:nvSpPr>
+          <p:cNvPr id="29" name="Rectangle 28"/>
+          <p:cNvSpPr/>
+          <p:nvPr/>
+        </p:nvSpPr>
+        <p:spPr>
+          <a:xfrm>
+            <a:off x="8092440" y="5074920"/>
+            <a:ext cx="2103120" cy="292608"/>
+          </a:xfrm>
+          <a:prstGeom prst="rect">
+            <a:avLst/>
+          </a:prstGeom>
+          <a:solidFill>
+            <a:srgbClr val="0B2947"/>
+          </a:solidFill>
+          <a:ln>
+            <a:noFill/>
+          </a:ln>
+          <a:effectLst/>
+        </p:spPr>
+        <p:style>
+          <a:lnRef idx="1">
+            <a:schemeClr val="accent1"/>
+          </a:lnRef>
+          <a:fillRef idx="3">
+            <a:schemeClr val="accent1"/>
+          </a:fillRef>
+          <a:effectRef idx="2">
+            <a:schemeClr val="accent1"/>
+          </a:effectRef>
+          <a:fontRef idx="minor">
+            <a:schemeClr val="lt1"/>
+          </a:fontRef>
+        </p:style>
+        <p:txBody>
+          <a:bodyPr rtlCol="0" anchor="ctr"/>
+          <a:lstStyle/>
+          <a:p>
+            <a:pPr algn="ctr"/>
+          </a:p>
+        </p:txBody>
+      </p:sp>
+      <p:sp>
+        <p:nvSpPr>
+          <p:cNvPr id="30" name="TextBox 29"/>
+          <p:cNvSpPr txBox="1"/>
+          <p:nvPr/>
+        </p:nvSpPr>
+        <p:spPr>
+          <a:xfrm>
+            <a:off x="8183879" y="5074920"/>
+            <a:ext cx="1920239" cy="292608"/>
+          </a:xfrm>
+          <a:prstGeom prst="rect">
+            <a:avLst/>
+          </a:prstGeom>
+          <a:noFill/>
+        </p:spPr>
+        <p:txBody>
+          <a:bodyPr wrap="square" lIns="0" rIns="0" tIns="0" bIns="0" anchor="ctr">
+            <a:spAutoFit/>
+          </a:bodyPr>
+          <a:lstStyle/>
+          <a:p>
+            <a:pPr algn="l"/>
+            <a:r>
+              <a:rPr sz="1050" b="1" i="0">
+                <a:solidFill>
+                  <a:srgbClr val="FFFFFF"/>
+                </a:solidFill>
+                <a:latin typeface="Segoe UI"/>
+              </a:rPr>
+              <a:t>DIM_TYPE_EVENEMENT</a:t>
+            </a:r>
+          </a:p>
+        </p:txBody>
+      </p:sp>
+      <p:sp>
+        <p:nvSpPr>
+          <p:cNvPr id="31" name="TextBox 30"/>
+          <p:cNvSpPr txBox="1"/>
+          <p:nvPr/>
+        </p:nvSpPr>
+        <p:spPr>
+          <a:xfrm>
+            <a:off x="8220456" y="5413248"/>
+            <a:ext cx="1847087" cy="201168"/>
+          </a:xfrm>
+          <a:prstGeom prst="rect">
+            <a:avLst/>
+          </a:prstGeom>
+          <a:noFill/>
+        </p:spPr>
+        <p:txBody>
+          <a:bodyPr wrap="square" lIns="0" rIns="0" tIns="0" bIns="0">
+            <a:spAutoFit/>
+          </a:bodyPr>
+          <a:lstStyle/>
+          <a:p>
+            <a:r>
+              <a:rPr sz="930" b="0" i="0" u="sng">
+                <a:solidFill>
+                  <a:srgbClr val="22303F"/>
+                </a:solidFill>
+                <a:latin typeface="Segoe UI"/>
+              </a:rPr>
+              <a:t>id_type_evenement (id)</a:t>
+            </a:r>
+          </a:p>
+        </p:txBody>
+      </p:sp>
+      <p:sp>
+        <p:nvSpPr>
+          <p:cNvPr id="32" name="TextBox 31"/>
+          <p:cNvSpPr txBox="1"/>
+          <p:nvPr/>
+        </p:nvSpPr>
+        <p:spPr>
+          <a:xfrm>
+            <a:off x="8220456" y="5614416"/>
+            <a:ext cx="1847087" cy="201168"/>
+          </a:xfrm>
+          <a:prstGeom prst="rect">
+            <a:avLst/>
+          </a:prstGeom>
+          <a:noFill/>
+        </p:spPr>
+        <p:txBody>
+          <a:bodyPr wrap="square" lIns="0" rIns="0" tIns="0" bIns="0">
+            <a:spAutoFit/>
+          </a:bodyPr>
+          <a:lstStyle/>
+          <a:p>
+            <a:r>
+              <a:rPr sz="930" b="0" i="0">
+                <a:solidFill>
+                  <a:srgbClr val="22303F"/>
+                </a:solidFill>
+                <a:latin typeface="Segoe UI"/>
+              </a:rPr>
+              <a:t>code_type</a:t>
+            </a:r>
+          </a:p>
+        </p:txBody>
+      </p:sp>
+      <p:sp>
+        <p:nvSpPr>
+          <p:cNvPr id="33" name="TextBox 32"/>
+          <p:cNvSpPr txBox="1"/>
+          <p:nvPr/>
+        </p:nvSpPr>
+        <p:spPr>
+          <a:xfrm>
+            <a:off x="8220456" y="5815584"/>
+            <a:ext cx="1847087" cy="201168"/>
+          </a:xfrm>
+          <a:prstGeom prst="rect">
+            <a:avLst/>
+          </a:prstGeom>
+          <a:noFill/>
+        </p:spPr>
+        <p:txBody>
+          <a:bodyPr wrap="square" lIns="0" rIns="0" tIns="0" bIns="0">
+            <a:spAutoFit/>
+          </a:bodyPr>
+          <a:lstStyle/>
+          <a:p>
+            <a:r>
+              <a:rPr sz="930" b="0" i="0">
+                <a:solidFill>
+                  <a:srgbClr val="22303F"/>
+                </a:solidFill>
+                <a:latin typeface="Segoe UI"/>
+              </a:rPr>
+              <a:t>libelle</a:t>
+            </a:r>
+          </a:p>
+        </p:txBody>
+      </p:sp>
+      <p:sp>
+        <p:nvSpPr>
+          <p:cNvPr id="34" name="Rectangle 33"/>
+          <p:cNvSpPr/>
+          <p:nvPr/>
+        </p:nvSpPr>
+        <p:spPr>
+          <a:xfrm>
+            <a:off x="2331720" y="5074920"/>
+            <a:ext cx="2103120" cy="987552"/>
+          </a:xfrm>
+          <a:prstGeom prst="rect">
+            <a:avLst/>
+          </a:prstGeom>
+          <a:solidFill>
+            <a:srgbClr val="FFFFFF"/>
+          </a:solidFill>
+          <a:ln w="16510">
+            <a:solidFill>
+              <a:srgbClr val="0B2947"/>
+            </a:solidFill>
+          </a:ln>
+          <a:effectLst/>
+        </p:spPr>
+        <p:style>
+          <a:lnRef idx="1">
+            <a:schemeClr val="accent1"/>
+          </a:lnRef>
+          <a:fillRef idx="3">
+            <a:schemeClr val="accent1"/>
+          </a:fillRef>
+          <a:effectRef idx="2">
+            <a:schemeClr val="accent1"/>
+          </a:effectRef>
+          <a:fontRef idx="minor">
+            <a:schemeClr val="lt1"/>
+          </a:fontRef>
+        </p:style>
+        <p:txBody>
+          <a:bodyPr rtlCol="0" anchor="ctr"/>
+          <a:lstStyle/>
+          <a:p>
+            <a:pPr algn="ctr"/>
+          </a:p>
+        </p:txBody>
+      </p:sp>
+      <p:sp>
+        <p:nvSpPr>
+          <p:cNvPr id="35" name="Rectangle 34"/>
+          <p:cNvSpPr/>
+          <p:nvPr/>
+        </p:nvSpPr>
+        <p:spPr>
+          <a:xfrm>
+            <a:off x="2331720" y="5074920"/>
+            <a:ext cx="2103120" cy="292608"/>
+          </a:xfrm>
+          <a:prstGeom prst="rect">
+            <a:avLst/>
+          </a:prstGeom>
+          <a:solidFill>
+            <a:srgbClr val="0B2947"/>
+          </a:solidFill>
+          <a:ln>
+            <a:noFill/>
+          </a:ln>
+          <a:effectLst/>
+        </p:spPr>
+        <p:style>
+          <a:lnRef idx="1">
+            <a:schemeClr val="accent1"/>
+          </a:lnRef>
+          <a:fillRef idx="3">
+            <a:schemeClr val="accent1"/>
+          </a:fillRef>
+          <a:effectRef idx="2">
+            <a:schemeClr val="accent1"/>
+          </a:effectRef>
+          <a:fontRef idx="minor">
+            <a:schemeClr val="lt1"/>
+          </a:fontRef>
+        </p:style>
+        <p:txBody>
+          <a:bodyPr rtlCol="0" anchor="ctr"/>
+          <a:lstStyle/>
+          <a:p>
+            <a:pPr algn="ctr"/>
+          </a:p>
+        </p:txBody>
+      </p:sp>
+      <p:sp>
+        <p:nvSpPr>
+          <p:cNvPr id="36" name="TextBox 35"/>
+          <p:cNvSpPr txBox="1"/>
+          <p:nvPr/>
+        </p:nvSpPr>
+        <p:spPr>
+          <a:xfrm>
+            <a:off x="2423160" y="5074920"/>
+            <a:ext cx="1920239" cy="292608"/>
+          </a:xfrm>
+          <a:prstGeom prst="rect">
+            <a:avLst/>
+          </a:prstGeom>
+          <a:noFill/>
+        </p:spPr>
+        <p:txBody>
+          <a:bodyPr wrap="square" lIns="0" rIns="0" tIns="0" bIns="0" anchor="ctr">
+            <a:spAutoFit/>
+          </a:bodyPr>
+          <a:lstStyle/>
+          <a:p>
+            <a:pPr algn="l"/>
+            <a:r>
+              <a:rPr sz="1050" b="1" i="0">
+                <a:solidFill>
+                  <a:srgbClr val="FFFFFF"/>
+                </a:solidFill>
+                <a:latin typeface="Segoe UI"/>
+              </a:rPr>
+              <a:t>DIM_CODE_EVENEMENT</a:t>
+            </a:r>
+          </a:p>
+        </p:txBody>
+      </p:sp>
+      <p:sp>
+        <p:nvSpPr>
+          <p:cNvPr id="37" name="TextBox 36"/>
+          <p:cNvSpPr txBox="1"/>
+          <p:nvPr/>
+        </p:nvSpPr>
+        <p:spPr>
+          <a:xfrm>
+            <a:off x="2459736" y="5413248"/>
+            <a:ext cx="1847087" cy="201168"/>
+          </a:xfrm>
+          <a:prstGeom prst="rect">
+            <a:avLst/>
+          </a:prstGeom>
+          <a:noFill/>
+        </p:spPr>
+        <p:txBody>
+          <a:bodyPr wrap="square" lIns="0" rIns="0" tIns="0" bIns="0">
+            <a:spAutoFit/>
+          </a:bodyPr>
+          <a:lstStyle/>
+          <a:p>
+            <a:r>
+              <a:rPr sz="930" b="0" i="0" u="sng">
+                <a:solidFill>
+                  <a:srgbClr val="22303F"/>
+                </a:solidFill>
+                <a:latin typeface="Segoe UI"/>
+              </a:rPr>
+              <a:t>id_code (id)</a:t>
+            </a:r>
+          </a:p>
+        </p:txBody>
+      </p:sp>
+      <p:sp>
+        <p:nvSpPr>
+          <p:cNvPr id="38" name="TextBox 37"/>
+          <p:cNvSpPr txBox="1"/>
+          <p:nvPr/>
+        </p:nvSpPr>
+        <p:spPr>
+          <a:xfrm>
+            <a:off x="2459736" y="5614416"/>
+            <a:ext cx="1847087" cy="201168"/>
+          </a:xfrm>
+          <a:prstGeom prst="rect">
+            <a:avLst/>
+          </a:prstGeom>
+          <a:noFill/>
+        </p:spPr>
+        <p:txBody>
+          <a:bodyPr wrap="square" lIns="0" rIns="0" tIns="0" bIns="0">
+            <a:spAutoFit/>
+          </a:bodyPr>
+          <a:lstStyle/>
+          <a:p>
+            <a:r>
+              <a:rPr sz="930" b="0" i="0">
+                <a:solidFill>
+                  <a:srgbClr val="22303F"/>
+                </a:solidFill>
+                <a:latin typeface="Segoe UI"/>
+              </a:rPr>
+              <a:t>id_type_evenement</a:t>
+            </a:r>
+          </a:p>
+        </p:txBody>
+      </p:sp>
+      <p:sp>
+        <p:nvSpPr>
+          <p:cNvPr id="39" name="TextBox 38"/>
+          <p:cNvSpPr txBox="1"/>
+          <p:nvPr/>
+        </p:nvSpPr>
+        <p:spPr>
+          <a:xfrm>
+            <a:off x="2459736" y="5815584"/>
+            <a:ext cx="1847087" cy="201168"/>
+          </a:xfrm>
+          <a:prstGeom prst="rect">
+            <a:avLst/>
+          </a:prstGeom>
+          <a:noFill/>
+        </p:spPr>
+        <p:txBody>
+          <a:bodyPr wrap="square" lIns="0" rIns="0" tIns="0" bIns="0">
+            <a:spAutoFit/>
+          </a:bodyPr>
+          <a:lstStyle/>
+          <a:p>
+            <a:r>
+              <a:rPr sz="930" b="0" i="0">
+                <a:solidFill>
+                  <a:srgbClr val="22303F"/>
+                </a:solidFill>
+                <a:latin typeface="Segoe UI"/>
+              </a:rPr>
+              <a:t>code_brut, libelle</a:t>
+            </a:r>
+          </a:p>
+        </p:txBody>
+      </p:sp>
+      <p:sp>
+        <p:nvSpPr>
+          <p:cNvPr id="40" name="Rectangle 39"/>
+          <p:cNvSpPr/>
+          <p:nvPr/>
+        </p:nvSpPr>
+        <p:spPr>
+          <a:xfrm>
+            <a:off x="365760" y="3209544"/>
+            <a:ext cx="2103120" cy="987552"/>
+          </a:xfrm>
+          <a:prstGeom prst="rect">
+            <a:avLst/>
+          </a:prstGeom>
+          <a:solidFill>
+            <a:srgbClr val="FFFFFF"/>
+          </a:solidFill>
+          <a:ln w="16510">
+            <a:solidFill>
+              <a:srgbClr val="0B2947"/>
+            </a:solidFill>
+          </a:ln>
+          <a:effectLst/>
+        </p:spPr>
+        <p:style>
+          <a:lnRef idx="1">
+            <a:schemeClr val="accent1"/>
+          </a:lnRef>
+          <a:fillRef idx="3">
+            <a:schemeClr val="accent1"/>
+          </a:fillRef>
+          <a:effectRef idx="2">
+            <a:schemeClr val="accent1"/>
+          </a:effectRef>
+          <a:fontRef idx="minor">
+            <a:schemeClr val="lt1"/>
+          </a:fontRef>
+        </p:style>
+        <p:txBody>
+          <a:bodyPr rtlCol="0" anchor="ctr"/>
+          <a:lstStyle/>
+          <a:p>
+            <a:pPr algn="ctr"/>
+          </a:p>
+        </p:txBody>
+      </p:sp>
+      <p:sp>
+        <p:nvSpPr>
+          <p:cNvPr id="41" name="Rectangle 40"/>
+          <p:cNvSpPr/>
+          <p:nvPr/>
+        </p:nvSpPr>
+        <p:spPr>
+          <a:xfrm>
+            <a:off x="365760" y="3209544"/>
+            <a:ext cx="2103120" cy="292608"/>
+          </a:xfrm>
+          <a:prstGeom prst="rect">
+            <a:avLst/>
+          </a:prstGeom>
+          <a:solidFill>
+            <a:srgbClr val="0B2947"/>
+          </a:solidFill>
+          <a:ln>
+            <a:noFill/>
+          </a:ln>
+          <a:effectLst/>
+        </p:spPr>
+        <p:style>
+          <a:lnRef idx="1">
+            <a:schemeClr val="accent1"/>
+          </a:lnRef>
+          <a:fillRef idx="3">
+            <a:schemeClr val="accent1"/>
+          </a:fillRef>
+          <a:effectRef idx="2">
+            <a:schemeClr val="accent1"/>
+          </a:effectRef>
+          <a:fontRef idx="minor">
+            <a:schemeClr val="lt1"/>
+          </a:fontRef>
+        </p:style>
+        <p:txBody>
+          <a:bodyPr rtlCol="0" anchor="ctr"/>
+          <a:lstStyle/>
+          <a:p>
+            <a:pPr algn="ctr"/>
+          </a:p>
+        </p:txBody>
+      </p:sp>
+      <p:sp>
+        <p:nvSpPr>
+          <p:cNvPr id="42" name="TextBox 41"/>
+          <p:cNvSpPr txBox="1"/>
+          <p:nvPr/>
+        </p:nvSpPr>
+        <p:spPr>
+          <a:xfrm>
+            <a:off x="457200" y="3209544"/>
+            <a:ext cx="1920239" cy="292608"/>
+          </a:xfrm>
+          <a:prstGeom prst="rect">
+            <a:avLst/>
+          </a:prstGeom>
+          <a:noFill/>
+        </p:spPr>
+        <p:txBody>
+          <a:bodyPr wrap="square" lIns="0" rIns="0" tIns="0" bIns="0" anchor="ctr">
+            <a:spAutoFit/>
+          </a:bodyPr>
+          <a:lstStyle/>
+          <a:p>
+            <a:pPr algn="l"/>
+            <a:r>
+              <a:rPr sz="1050" b="1" i="0">
+                <a:solidFill>
+                  <a:srgbClr val="FFFFFF"/>
+                </a:solidFill>
+                <a:latin typeface="Segoe UI"/>
+              </a:rPr>
+              <a:t>DIM_OPERATEUR</a:t>
+            </a:r>
+          </a:p>
+        </p:txBody>
+      </p:sp>
+      <p:sp>
+        <p:nvSpPr>
+          <p:cNvPr id="43" name="TextBox 42"/>
+          <p:cNvSpPr txBox="1"/>
+          <p:nvPr/>
+        </p:nvSpPr>
+        <p:spPr>
+          <a:xfrm>
+            <a:off x="493776" y="3547871"/>
+            <a:ext cx="1847087" cy="201168"/>
+          </a:xfrm>
+          <a:prstGeom prst="rect">
+            <a:avLst/>
+          </a:prstGeom>
+          <a:noFill/>
+        </p:spPr>
+        <p:txBody>
+          <a:bodyPr wrap="square" lIns="0" rIns="0" tIns="0" bIns="0">
+            <a:spAutoFit/>
+          </a:bodyPr>
+          <a:lstStyle/>
+          <a:p>
+            <a:r>
+              <a:rPr sz="930" b="0" i="0" u="sng">
+                <a:solidFill>
+                  <a:srgbClr val="22303F"/>
+                </a:solidFill>
+                <a:latin typeface="Segoe UI"/>
+              </a:rPr>
+              <a:t>id_operateur (id)</a:t>
+            </a:r>
+          </a:p>
+        </p:txBody>
+      </p:sp>
+      <p:sp>
+        <p:nvSpPr>
+          <p:cNvPr id="44" name="TextBox 43"/>
+          <p:cNvSpPr txBox="1"/>
+          <p:nvPr/>
+        </p:nvSpPr>
+        <p:spPr>
+          <a:xfrm>
+            <a:off x="493776" y="3749039"/>
+            <a:ext cx="1847087" cy="201168"/>
+          </a:xfrm>
+          <a:prstGeom prst="rect">
+            <a:avLst/>
+          </a:prstGeom>
+          <a:noFill/>
+        </p:spPr>
+        <p:txBody>
+          <a:bodyPr wrap="square" lIns="0" rIns="0" tIns="0" bIns="0">
+            <a:spAutoFit/>
+          </a:bodyPr>
+          <a:lstStyle/>
+          <a:p>
+            <a:r>
+              <a:rPr sz="930" b="0" i="0">
+                <a:solidFill>
+                  <a:srgbClr val="22303F"/>
+                </a:solidFill>
+                <a:latin typeface="Segoe UI"/>
+              </a:rPr>
+              <a:t>matricule, nom</a:t>
+            </a:r>
+          </a:p>
+        </p:txBody>
+      </p:sp>
+      <p:sp>
+        <p:nvSpPr>
+          <p:cNvPr id="45" name="TextBox 44"/>
+          <p:cNvSpPr txBox="1"/>
+          <p:nvPr/>
+        </p:nvSpPr>
+        <p:spPr>
+          <a:xfrm>
+            <a:off x="493776" y="3950207"/>
+            <a:ext cx="1847087" cy="201168"/>
+          </a:xfrm>
+          <a:prstGeom prst="rect">
+            <a:avLst/>
+          </a:prstGeom>
+          <a:noFill/>
+        </p:spPr>
+        <p:txBody>
+          <a:bodyPr wrap="square" lIns="0" rIns="0" tIns="0" bIns="0">
+            <a:spAutoFit/>
+          </a:bodyPr>
+          <a:lstStyle/>
+          <a:p>
+            <a:r>
+              <a:rPr sz="930" b="0" i="0">
+                <a:solidFill>
+                  <a:srgbClr val="22303F"/>
+                </a:solidFill>
+                <a:latin typeface="Segoe UI"/>
+              </a:rPr>
+              <a:t>equipe</a:t>
+            </a:r>
+          </a:p>
+        </p:txBody>
+      </p:sp>
+      <p:sp>
+        <p:nvSpPr>
+          <p:cNvPr id="46" name="TextBox 45"/>
+          <p:cNvSpPr txBox="1"/>
+          <p:nvPr/>
+        </p:nvSpPr>
+        <p:spPr>
+          <a:xfrm>
+            <a:off x="365760" y="4224528"/>
+            <a:ext cx="2103120" cy="201168"/>
+          </a:xfrm>
+          <a:prstGeom prst="rect">
+            <a:avLst/>
+          </a:prstGeom>
+          <a:noFill/>
+        </p:spPr>
+        <p:txBody>
+          <a:bodyPr wrap="square" lIns="0" rIns="0" tIns="0" bIns="0">
+            <a:spAutoFit/>
+          </a:bodyPr>
+          <a:lstStyle/>
+          <a:p>
+            <a:pPr algn="ctr"/>
+            <a:r>
+              <a:rPr sz="700" b="0" i="1">
+                <a:solidFill>
+                  <a:srgbClr val="55606E"/>
+                </a:solidFill>
+                <a:latin typeface="Segoe UI"/>
+              </a:rPr>
+              <a:t>Anticipée (GMAO) — non peuplée</a:t>
+            </a:r>
+          </a:p>
+        </p:txBody>
+      </p:sp>
+      <p:cxnSp>
+        <p:nvCxnSpPr>
+          <p:cNvPr id="47" name="Connector 46"/>
+          <p:cNvCxnSpPr/>
+          <p:nvPr/>
+        </p:nvCxnSpPr>
+        <p:spPr>
+          <a:xfrm flipV="1">
+            <a:off x="6080760" y="2084832"/>
+            <a:ext cx="0" cy="621792"/>
+          </a:xfrm>
+          <a:prstGeom prst="line">
+            <a:avLst/>
+          </a:prstGeom>
+          <a:ln w="20320">
+            <a:solidFill>
+              <a:srgbClr val="0A66C2"/>
+            </a:solidFill>
+          </a:ln>
+        </p:spPr>
+        <p:style>
+          <a:lnRef idx="2">
+            <a:schemeClr val="accent1"/>
+          </a:lnRef>
+          <a:fillRef idx="0">
+            <a:schemeClr val="accent1"/>
+          </a:fillRef>
+          <a:effectRef idx="1">
+            <a:schemeClr val="accent1"/>
+          </a:effectRef>
+          <a:fontRef idx="minor">
+            <a:schemeClr val="tx1"/>
+          </a:fontRef>
+        </p:style>
+      </p:cxnSp>
+      <p:cxnSp>
+        <p:nvCxnSpPr>
+          <p:cNvPr id="48" name="Connector 47"/>
+          <p:cNvCxnSpPr/>
+          <p:nvPr/>
+        </p:nvCxnSpPr>
+        <p:spPr>
+          <a:xfrm>
+            <a:off x="7315200" y="3304641"/>
+            <a:ext cx="914400" cy="398679"/>
+          </a:xfrm>
+          <a:prstGeom prst="line">
+            <a:avLst/>
+          </a:prstGeom>
+          <a:ln w="20320">
+            <a:solidFill>
+              <a:srgbClr val="0A66C2"/>
+            </a:solidFill>
+          </a:ln>
+        </p:spPr>
+        <p:style>
+          <a:lnRef idx="2">
+            <a:schemeClr val="accent1"/>
+          </a:lnRef>
+          <a:fillRef idx="0">
+            <a:schemeClr val="accent1"/>
+          </a:fillRef>
+          <a:effectRef idx="1">
+            <a:schemeClr val="accent1"/>
+          </a:effectRef>
+          <a:fontRef idx="minor">
+            <a:schemeClr val="tx1"/>
+          </a:fontRef>
+        </p:style>
+      </p:cxnSp>
+      <p:cxnSp>
+        <p:nvCxnSpPr>
+          <p:cNvPr id="49" name="Connector 48"/>
+          <p:cNvCxnSpPr/>
+          <p:nvPr/>
+        </p:nvCxnSpPr>
+        <p:spPr>
+          <a:xfrm>
+            <a:off x="7315200" y="4401007"/>
+            <a:ext cx="777240" cy="1167689"/>
+          </a:xfrm>
+          <a:prstGeom prst="line">
+            <a:avLst/>
+          </a:prstGeom>
+          <a:ln w="20320">
+            <a:solidFill>
+              <a:srgbClr val="0A66C2"/>
+            </a:solidFill>
+          </a:ln>
+        </p:spPr>
+        <p:style>
+          <a:lnRef idx="2">
+            <a:schemeClr val="accent1"/>
+          </a:lnRef>
+          <a:fillRef idx="0">
+            <a:schemeClr val="accent1"/>
+          </a:fillRef>
+          <a:effectRef idx="1">
+            <a:schemeClr val="accent1"/>
+          </a:effectRef>
+          <a:fontRef idx="minor">
+            <a:schemeClr val="tx1"/>
+          </a:fontRef>
+        </p:style>
+      </p:cxnSp>
+      <p:cxnSp>
+        <p:nvCxnSpPr>
+          <p:cNvPr id="50" name="Connector 49"/>
+          <p:cNvCxnSpPr/>
+          <p:nvPr/>
+        </p:nvCxnSpPr>
+        <p:spPr>
+          <a:xfrm flipH="1">
+            <a:off x="4434840" y="4401007"/>
+            <a:ext cx="411480" cy="1167689"/>
+          </a:xfrm>
+          <a:prstGeom prst="line">
+            <a:avLst/>
+          </a:prstGeom>
+          <a:ln w="20320">
+            <a:solidFill>
+              <a:srgbClr val="0A66C2"/>
+            </a:solidFill>
+          </a:ln>
+        </p:spPr>
+        <p:style>
+          <a:lnRef idx="2">
+            <a:schemeClr val="accent1"/>
+          </a:lnRef>
+          <a:fillRef idx="0">
+            <a:schemeClr val="accent1"/>
+          </a:fillRef>
+          <a:effectRef idx="1">
+            <a:schemeClr val="accent1"/>
+          </a:effectRef>
+          <a:fontRef idx="minor">
+            <a:schemeClr val="tx1"/>
+          </a:fontRef>
+        </p:style>
+      </p:cxnSp>
+      <p:cxnSp>
+        <p:nvCxnSpPr>
+          <p:cNvPr id="51" name="Connector 50"/>
+          <p:cNvCxnSpPr/>
+          <p:nvPr/>
+        </p:nvCxnSpPr>
+        <p:spPr>
+          <a:xfrm flipH="1">
+            <a:off x="2468879" y="3304641"/>
+            <a:ext cx="2377441" cy="398679"/>
+          </a:xfrm>
+          <a:prstGeom prst="line">
+            <a:avLst/>
+          </a:prstGeom>
+          <a:ln w="20320">
+            <a:solidFill>
+              <a:srgbClr val="F5C344"/>
+            </a:solidFill>
+          </a:ln>
+        </p:spPr>
+        <p:style>
+          <a:lnRef idx="2">
+            <a:schemeClr val="accent1"/>
+          </a:lnRef>
+          <a:fillRef idx="0">
+            <a:schemeClr val="accent1"/>
+          </a:fillRef>
+          <a:effectRef idx="1">
+            <a:schemeClr val="accent1"/>
+          </a:effectRef>
+          <a:fontRef idx="minor">
+            <a:schemeClr val="tx1"/>
+          </a:fontRef>
+        </p:style>
+      </p:cxnSp>
+      <p:sp>
+        <p:nvSpPr>
+          <p:cNvPr id="52" name="Rounded Rectangle 51"/>
+          <p:cNvSpPr/>
+          <p:nvPr/>
+        </p:nvSpPr>
+        <p:spPr>
+          <a:xfrm>
+            <a:off x="411480" y="6089904"/>
+            <a:ext cx="11109960" cy="274320"/>
+          </a:xfrm>
+          <a:prstGeom prst="roundRect">
+            <a:avLst>
+              <a:gd name="adj" fmla="val 40000"/>
+            </a:avLst>
+          </a:prstGeom>
+          <a:solidFill>
+            <a:srgbClr val="FDF1D2"/>
+          </a:solidFill>
+          <a:ln>
+            <a:noFill/>
+          </a:ln>
+          <a:effectLst/>
+        </p:spPr>
+        <p:style>
+          <a:lnRef idx="1">
+            <a:schemeClr val="accent1"/>
+          </a:lnRef>
+          <a:fillRef idx="3">
+            <a:schemeClr val="accent1"/>
+          </a:fillRef>
+          <a:effectRef idx="2">
+            <a:schemeClr val="accent1"/>
+          </a:effectRef>
+          <a:fontRef idx="minor">
+            <a:schemeClr val="lt1"/>
+          </a:fontRef>
+        </p:style>
+        <p:txBody>
+          <a:bodyPr rtlCol="0" anchor="ctr"/>
+          <a:lstStyle/>
+          <a:p>
+            <a:pPr algn="ctr"/>
+          </a:p>
+        </p:txBody>
+      </p:sp>
+      <p:sp>
+        <p:nvSpPr>
+          <p:cNvPr id="53" name="Rounded Rectangle 52"/>
+          <p:cNvSpPr/>
+          <p:nvPr/>
+        </p:nvSpPr>
+        <p:spPr>
+          <a:xfrm>
+            <a:off x="685800" y="6117336"/>
+            <a:ext cx="914400" cy="219456"/>
+          </a:xfrm>
+          <a:prstGeom prst="roundRect">
+            <a:avLst>
+              <a:gd name="adj" fmla="val 50000"/>
+            </a:avLst>
+          </a:prstGeom>
+          <a:solidFill>
+            <a:srgbClr val="F5C344"/>
+          </a:solidFill>
+          <a:ln>
+            <a:noFill/>
+          </a:ln>
+          <a:effectLst/>
+        </p:spPr>
+        <p:style>
+          <a:lnRef idx="1">
+            <a:schemeClr val="accent1"/>
+          </a:lnRef>
+          <a:fillRef idx="3">
+            <a:schemeClr val="accent1"/>
+          </a:fillRef>
+          <a:effectRef idx="2">
+            <a:schemeClr val="accent1"/>
+          </a:effectRef>
+          <a:fontRef idx="minor">
+            <a:schemeClr val="lt1"/>
+          </a:fontRef>
+        </p:style>
+        <p:txBody>
+          <a:bodyPr rtlCol="0" anchor="ctr" lIns="50800" rIns="50800" tIns="0" bIns="0" wrap="square"/>
+          <a:lstStyle/>
+          <a:p>
+            <a:pPr algn="ctr"/>
+            <a:r>
+              <a:rPr sz="850" b="1" i="0">
+                <a:solidFill>
+                  <a:srgbClr val="0B2947"/>
+                </a:solidFill>
+                <a:latin typeface="Segoe UI"/>
+              </a:rPr>
+              <a:t>ERREUR</a:t>
+            </a:r>
+          </a:p>
+        </p:txBody>
+      </p:sp>
+      <p:sp>
+        <p:nvSpPr>
+          <p:cNvPr id="54" name="Rounded Rectangle 53"/>
+          <p:cNvSpPr/>
+          <p:nvPr/>
+        </p:nvSpPr>
+        <p:spPr>
+          <a:xfrm>
+            <a:off x="1691640" y="6117336"/>
+            <a:ext cx="914400" cy="219456"/>
+          </a:xfrm>
+          <a:prstGeom prst="roundRect">
+            <a:avLst>
+              <a:gd name="adj" fmla="val 50000"/>
+            </a:avLst>
+          </a:prstGeom>
+          <a:solidFill>
+            <a:srgbClr val="F5C344"/>
+          </a:solidFill>
+          <a:ln>
+            <a:noFill/>
+          </a:ln>
+          <a:effectLst/>
+        </p:spPr>
+        <p:style>
+          <a:lnRef idx="1">
+            <a:schemeClr val="accent1"/>
+          </a:lnRef>
+          <a:fillRef idx="3">
+            <a:schemeClr val="accent1"/>
+          </a:fillRef>
+          <a:effectRef idx="2">
+            <a:schemeClr val="accent1"/>
+          </a:effectRef>
+          <a:fontRef idx="minor">
+            <a:schemeClr val="lt1"/>
+          </a:fontRef>
+        </p:style>
+        <p:txBody>
+          <a:bodyPr rtlCol="0" anchor="ctr" lIns="50800" rIns="50800" tIns="0" bIns="0" wrap="square"/>
+          <a:lstStyle/>
+          <a:p>
+            <a:pPr algn="ctr"/>
+            <a:r>
+              <a:rPr sz="850" b="1" i="0">
+                <a:solidFill>
+                  <a:srgbClr val="0B2947"/>
+                </a:solidFill>
+                <a:latin typeface="Segoe UI"/>
+              </a:rPr>
+              <a:t>PANNE</a:t>
+            </a:r>
+          </a:p>
+        </p:txBody>
+      </p:sp>
+      <p:sp>
+        <p:nvSpPr>
+          <p:cNvPr id="55" name="Rounded Rectangle 54"/>
+          <p:cNvSpPr/>
+          <p:nvPr/>
+        </p:nvSpPr>
+        <p:spPr>
+          <a:xfrm>
+            <a:off x="2697480" y="6117336"/>
+            <a:ext cx="1234440" cy="219456"/>
+          </a:xfrm>
+          <a:prstGeom prst="roundRect">
+            <a:avLst>
+              <a:gd name="adj" fmla="val 50000"/>
+            </a:avLst>
+          </a:prstGeom>
+          <a:solidFill>
+            <a:srgbClr val="F5C344"/>
+          </a:solidFill>
+          <a:ln>
+            <a:noFill/>
+          </a:ln>
+          <a:effectLst/>
+        </p:spPr>
+        <p:style>
+          <a:lnRef idx="1">
+            <a:schemeClr val="accent1"/>
+          </a:lnRef>
+          <a:fillRef idx="3">
+            <a:schemeClr val="accent1"/>
+          </a:fillRef>
+          <a:effectRef idx="2">
+            <a:schemeClr val="accent1"/>
+          </a:effectRef>
+          <a:fontRef idx="minor">
+            <a:schemeClr val="lt1"/>
+          </a:fontRef>
+        </p:style>
+        <p:txBody>
+          <a:bodyPr rtlCol="0" anchor="ctr" lIns="50800" rIns="50800" tIns="0" bIns="0" wrap="square"/>
+          <a:lstStyle/>
+          <a:p>
+            <a:pPr algn="ctr"/>
+            <a:r>
+              <a:rPr sz="850" b="1" i="0">
+                <a:solidFill>
+                  <a:srgbClr val="0B2947"/>
+                </a:solidFill>
+                <a:latin typeface="Segoe UI"/>
+              </a:rPr>
+              <a:t>MAINTENANCE</a:t>
+            </a:r>
+          </a:p>
+        </p:txBody>
+      </p:sp>
+      <p:sp>
+        <p:nvSpPr>
+          <p:cNvPr id="56" name="TextBox 55"/>
+          <p:cNvSpPr txBox="1"/>
+          <p:nvPr/>
+        </p:nvSpPr>
+        <p:spPr>
+          <a:xfrm>
+            <a:off x="4069080" y="6108192"/>
+            <a:ext cx="7315200" cy="237744"/>
+          </a:xfrm>
+          <a:prstGeom prst="rect">
+            <a:avLst/>
+          </a:prstGeom>
+          <a:noFill/>
+        </p:spPr>
+        <p:txBody>
+          <a:bodyPr wrap="square" lIns="0" rIns="0" tIns="0" bIns="0" anchor="ctr">
+            <a:spAutoFit/>
+          </a:bodyPr>
+          <a:lstStyle/>
+          <a:p>
+            <a:pPr algn="l"/>
+            <a:r>
+              <a:rPr sz="860" b="0" i="1">
+                <a:solidFill>
+                  <a:srgbClr val="0B2947"/>
+                </a:solidFill>
+                <a:latin typeface="Segoe UI"/>
+              </a:rPr>
+              <a:t>→ fusionnées ici en UNE table de faits, distinguées par id_type_evenement (voir page 2 pour le détail conceptuel)</a:t>
+            </a:r>
+          </a:p>
+        </p:txBody>
+      </p:sp>
+      <p:sp>
+        <p:nvSpPr>
+          <p:cNvPr id="57" name="TextBox 56"/>
+          <p:cNvSpPr txBox="1"/>
+          <p:nvPr/>
+        </p:nvSpPr>
+        <p:spPr>
+          <a:xfrm>
+            <a:off x="365760" y="6473952"/>
+            <a:ext cx="5029200" cy="274320"/>
+          </a:xfrm>
+          <a:prstGeom prst="rect">
+            <a:avLst/>
+          </a:prstGeom>
+          <a:noFill/>
+        </p:spPr>
+        <p:txBody>
+          <a:bodyPr wrap="square" lIns="0" rIns="0" tIns="0" bIns="0">
+            <a:spAutoFit/>
+          </a:bodyPr>
+          <a:lstStyle/>
+          <a:p>
+            <a:pPr algn="l"/>
+            <a:r>
+              <a:rPr sz="900" b="0" i="0">
+                <a:solidFill>
+                  <a:srgbClr val="55606E"/>
+                </a:solidFill>
+                <a:latin typeface="Segoe UI"/>
+              </a:rPr>
+              <a:t>Bloc 2 — Architecture de données pour l'IA</a:t>
+            </a:r>
+          </a:p>
+        </p:txBody>
+      </p:sp>
+      <p:sp>
+        <p:nvSpPr>
+          <p:cNvPr id="58" name="Rounded Rectangle 57"/>
           <p:cNvSpPr/>
           <p:nvPr/>
         </p:nvSpPr>

</xml_diff>

<commit_message>
Self-host Kafka and ClickHouse instead of OVHcloud managed offers
Les offres managees OVHcloud pour Kafka (~139 $/noeud, minimum 3
noeuds) et ClickHouse (~213 $/noeud) demarrent a plusieurs centaines
de dollars par mois chacune - pensees pour une haute disponibilite de
production, disproportionne pour ce cas fictif de certification et
incompatible avec le credit d'essai Public Cloud (200 EUR / 1 mois).
Les deux tournent desormais sur de petites instances Compute
auto-gerees, memes principes de securite (vRack, chiffrement) sans le
cout du multi-noeud managed. PostgreSQL managE et Object Storage
restent inchanges (tarifs d'entree de gamme accessibles).

Diagramme (page 1) et README mis a jour en consequence.
</commit_message>
<xml_diff>
--- a/diagram/architecture-edge-cloud.pptx
+++ b/diagram/architecture-edge-cloud.pptx
@@ -4546,7 +4546,7 @@
                 </a:solidFill>
                 <a:latin typeface="Segoe UI"/>
               </a:rPr>
-              <a:t>Broker d'ingestion — Kafka managé (OVHcloud)</a:t>
+              <a:t>Broker d'ingestion — Kafka auto-hébergé (VM dédiée)</a:t>
             </a:r>
           </a:p>
         </p:txBody>
@@ -5462,7 +5462,7 @@
                 </a:solidFill>
                 <a:latin typeface="Segoe UI"/>
               </a:rPr>
-              <a:t>ClickHouse managé</a:t>
+              <a:t>ClickHouse (VM)</a:t>
             </a:r>
           </a:p>
         </p:txBody>

</xml_diff>

<commit_message>
mentionne Scaleway la ou le vrai deploiement est decrit
Le README et le diagramme distinguent maintenant le raisonnement
architectural (generique, valable independamment du fournisseur) de
la description du deploiement REEL effectue, qui nomme Scaleway
explicitement — coherent avec le reste du projet (documenter la
realite, pas rester evasif sur ce qui a ete concretement fait).
</commit_message>
<xml_diff>
--- a/diagram/architecture-edge-cloud.pptx
+++ b/diagram/architecture-edge-cloud.pptx
@@ -3207,7 +3207,7 @@
                 </a:solidFill>
                 <a:latin typeface="Segoe UI"/>
               </a:rPr>
-              <a:t>Bloc 2 — Architecture hybride Edge / Cloud  ·  Dataset Microsoft Azure Predictive Maintenance  ·  Cloud souverain européen</a:t>
+              <a:t>Bloc 2 — Architecture hybride Edge / Cloud  ·  Dataset Microsoft Azure Predictive Maintenance  ·  Cloud souverain européen (Scaleway)</a:t>
             </a:r>
           </a:p>
         </p:txBody>
@@ -4296,7 +4296,7 @@
                 </a:solidFill>
                 <a:latin typeface="Segoe UI"/>
               </a:rPr>
-              <a:t>Cloud souverain, conforme RGPD</a:t>
+              <a:t>Scaleway (France) — cloud souverain, conforme RGPD</a:t>
             </a:r>
           </a:p>
         </p:txBody>

</xml_diff>